<commit_message>
docs(deck): professional-voice pass on the data-mesh decks
Remove em dashes, chapter/section cross-references, and ban-tier verbal
tics (deliberately, earns its place, load-bearing, worth noticing, honest,
on purpose, not a toy, rest of this deck) from The Data Mesh 101 and
Data Mesh on OpenShift pptxgenjs sources, then rebuild both decks.
</commit_message>
<xml_diff>
--- a/presentation/data-mesh-101/The_Data_Mesh_101.pptx
+++ b/presentation/data-mesh-101/The_Data_Mesh_101.pptx
@@ -515,7 +515,7 @@
           <a:p>
             <a:r>
               <a:rPr lang="en-US" dirty="0"/>
-              <a:t>Welcome. This deck makes the case for data mesh by first grounding the audience in the landscape of data architectures that came before it. We'll walk through four patterns — data pipelines, data warehouses, data lakes, and data mesh — and show what each solves, where each stalls, and why the mesh is a different kind of answer. Then we'll define data mesh precisely through Dehghani's four principles.</a:t>
+              <a:t>Welcome. This deck makes the case for data mesh by first grounding the audience in the landscape of data architectures that came before it. We'll walk through four patterns (data pipelines, data warehouses, data lakes, and data mesh) and show what each solves, where each stalls, and why the mesh is a different kind of answer. Then we'll define data mesh precisely through Dehghani's four principles.</a:t>
             </a:r>
             <a:endParaRPr lang="en-US" dirty="0"/>
           </a:p>
@@ -603,8 +603,8 @@
           <a:p>
             <a:r>
               <a:rPr lang="en-US" dirty="0"/>
-              <a:t>Walk the diagram. Top band: federated computational governance — standards enforced by the platform, automatically. The 2x2 grid shows four domain data products — Orders, Inventory, Payment, Shipping — each a red card because this is the target pattern. Each card shows: the domain name, what it owns, 'owns its data,' three API port pills (REST, gRPC, Events), and 'team-owned' at the bottom. The bidirectional red arrows between domains show inter-domain communication — products talking to products.
-Bottom band: the self-serve data platform — shared infrastructure every domain consumes: streaming, storage, mesh, observability. This is the organizational shape that's different: no central data team owning everything. Each domain owns its own data; the platform and governance make them interoperable. The contrast with the warehouse slide should be visceral: there's no 'Central Data Team' card here.</a:t>
+              <a:t>Walk the diagram. Top band: federated computational governance, with standards enforced by the platform automatically. The 2x2 grid shows four domain data products (Orders, Inventory, Payment, Shipping), each a red card because this is the target pattern. Each card shows: the domain name, what it owns, 'owns its data,' three API port pills (REST, gRPC, Events), and 'team-owned' at the bottom. The bidirectional red arrows between domains show inter-domain communication, products talking to products.
+Bottom band: the self-serve data platform, shared infrastructure every domain consumes: streaming, storage, mesh, observability. This is the organizational shape that's different: no central data team owning everything. Each domain owns its own data; the platform and governance make them interoperable. The contrast with the warehouse slide should be visceral: there's no 'Central Data Team' card here.</a:t>
             </a:r>
             <a:endParaRPr lang="en-US" dirty="0"/>
           </a:p>
@@ -692,8 +692,8 @@
           <a:p>
             <a:r>
               <a:rPr lang="en-US" dirty="0"/>
-              <a:t>The synthesis slide. Walk left to right through the four columns. Pipelines (blue): solved the movement problem, but the limitation is pipeline sprawl and no ownership model. Warehouses (orange): solved the truth problem — a single governed view — but the limitation is the central team bottleneck. Lakes (green): solved the flexibility problem — any format, any workload — but the limitation is swamp risk and the same organizational bottleneck. Mesh (red): solves the organizational scaling problem — decentralized ownership — but requires organizational maturity.
-The bottom band makes the organizational dimension explicit: point-to-point → centralized team → centralized team (bigger) → decentralized ownership. The progression isn't 'each is better than the last' — it's 'each solves a different problem.' A pipeline is still right when movement is the problem. A warehouse is still right when truth is the problem. A lake is still right when flexibility is the problem. The mesh is right when the bottleneck is organizational.</a:t>
+              <a:t>The synthesis slide. Walk left to right through the four columns. Pipelines (blue): solved the movement problem, but the limitation is pipeline sprawl and no ownership model. Warehouses (orange): solved the truth problem (a single governed view), but the limitation is the central team bottleneck. Lakes (green): solved the flexibility problem (any format, any workload), but the limitation is swamp risk and the same organizational bottleneck. Mesh (red): solves the organizational scaling problem (decentralized ownership), but requires organizational maturity.
+The bottom band makes the organizational dimension explicit: point-to-point, then centralized team, then centralized team (bigger), then decentralized ownership. The progression isn't 'each is better than the last'; it's 'each solves a different problem.' A pipeline is still right when movement is the problem. A warehouse is still right when truth is the problem. A lake is still right when flexibility is the problem. The mesh is right when the bottleneck is organizational.</a:t>
             </a:r>
             <a:endParaRPr lang="en-US" dirty="0"/>
           </a:p>
@@ -784,9 +784,9 @@
               <a:t>This is the fitness slide. Not every organization needs a mesh. The question is whether the bottleneck is technical (better tools solve it) or organizational (who owns what). Walk each:
 • Pipelines fit when the plumbing is simple enough that sprawl hasn't started. A handful of integrations, stable flows, known sources and destinations. Don't add complexity before the problem demands it.
 • Warehouses fit when the organization needs a single source of truth for BI and reporting, and a central team has the capacity to curate the data. If the bottleneck is 'we don't know the truth,' the warehouse is the answer.
-• Lakes fit when the data is heterogeneous — logs, events, images, ML training sets — and the scale or workload patterns exceed what a warehouse handles. The bottleneck is format rigidity, not organizational ownership.
-• Mesh fits when the organization has outgrown centralized ownership. Many domains, many consumers, and the central team is the constraint. The bottleneck is organizational — not which tool to buy. The organization also needs the maturity to operate federated ownership: domain teams that can treat data as a product, a platform team that can provide self-serve infrastructure, and governance that works through automation.
-Telling people when NOT to use a mesh builds credibility for when you say they should.</a:t>
+• Lakes fit when the data is heterogeneous (logs, events, images, ML training sets) and the scale or workload patterns exceed what a warehouse handles. The bottleneck is format rigidity, not organizational ownership.
+• Mesh fits when the organization has outgrown centralized ownership. Many domains, many consumers, and the central team is the constraint. The bottleneck is organizational, not which tool to buy. The organization also needs the maturity to operate federated ownership: domain teams that can treat data as a product, a platform team that can provide self-serve infrastructure, and governance that works through automation.
+Naming when not to use a mesh makes the recommendation to use one more credible.</a:t>
             </a:r>
             <a:endParaRPr lang="en-US" dirty="0"/>
           </a:p>
@@ -874,7 +874,7 @@
           <a:p>
             <a:r>
               <a:rPr lang="en-US" dirty="0"/>
-              <a:t>Closing slide. The one-sentence definition: a mesh is the network of products plus the platform and standards that let them interoperate. And the grounding from today: each pattern we walked through solved a real problem — the mesh solves the organizational one they all left behind. Open for questions.</a:t>
+              <a:t>Closing slide. The one-sentence definition: a mesh is the network of products plus the platform and standards that let them interoperate. And the grounding from today: each pattern we walked through solved a real problem; the mesh solves the organizational one they all left behind. Open for questions.</a:t>
             </a:r>
             <a:endParaRPr lang="en-US" dirty="0"/>
           </a:p>
@@ -1050,7 +1050,7 @@
           <a:p>
             <a:r>
               <a:rPr lang="en-US" dirty="0"/>
-              <a:t>Section 1 covers the data architecture landscape. The goal is to build the audience's understanding of why data mesh exists by walking through the patterns that came before it. Each pattern solved a real problem; the mesh is not a replacement for all of them but a response to a specific organizational scaling challenge. We'll spend enough time on each to make the mesh's value proposition concrete rather than abstract.</a:t>
+              <a:t>The data architecture landscape sets up why data mesh exists. The goal is to build the audience's understanding of why data mesh exists by walking through the patterns that came before it. Each pattern solved a real problem; the mesh is not a replacement for all of them but a response to a specific organizational scaling challenge. We'll spend enough time on each to make the mesh's value proposition concrete rather than abstract.</a:t>
             </a:r>
             <a:endParaRPr lang="en-US" dirty="0"/>
           </a:p>
@@ -1138,7 +1138,7 @@
           <a:p>
             <a:r>
               <a:rPr lang="en-US" dirty="0"/>
-              <a:t>Start with the oldest pattern. Define pipelines concretely: extract-transform-load, or extract-load-transform. The distinction matters (where does the business logic live?) but both are the same shape: linear, bespoke, point-to-point. The limitation is pipeline sprawl — and it's combinatorial. 15 sources times 5 destinations isn't 20 pipelines, it's closer to 75, each with its own schedule, transformation logic, and failure modes. Nobody owns the data in a pipeline — the pipeline is plumbing, not a product. That distinction becomes central when we get to data mesh. The sprawl is what the warehouse was designed to tame.</a:t>
+              <a:t>Start with the oldest pattern. Define pipelines concretely: extract-transform-load, or extract-load-transform. The distinction matters (where does the business logic live?) but both are the same shape: linear, bespoke, point-to-point. The limitation is pipeline sprawl, and it's combinatorial. 15 sources times 5 destinations isn't 20 pipelines, it's closer to 75, each with its own schedule, transformation logic, and failure modes. Nobody owns the data in a pipeline; the pipeline is plumbing, not a product. That distinction becomes central when we get to data mesh. The sprawl is what the warehouse was designed to tame.</a:t>
             </a:r>
             <a:endParaRPr lang="en-US" dirty="0"/>
           </a:p>
@@ -1226,7 +1226,7 @@
           <a:p>
             <a:r>
               <a:rPr lang="en-US" dirty="0"/>
-              <a:t>Walk the diagram left to right. Sources on the left — CRM, ERP, logs, events — each with its own characteristics and cadence. The ETL box in the center is one pipeline, with its own transformation logic, schedule, and failure modes. Two destinations on the right. Now look at the bottom callout: pipeline sprawl. Each new source or destination doesn't just add one pipeline — it adds as many as there are things on the other side. The dashed lines show the fan-out. At organizational scale, this becomes unmanageable: nobody can see the whole picture, nobody owns the data in transit, and when something breaks at 2 a.m., the question 'whose problem is this?' rarely has a clear answer.</a:t>
+              <a:t>Walk the diagram left to right. Sources on the left (CRM, ERP, logs, events), each with its own characteristics and cadence. The ETL box in the center is one pipeline, with its own transformation logic, schedule, and failure modes. Two destinations on the right. Now look at the bottom callout: pipeline sprawl. Each new source or destination doesn't just add one pipeline; it adds as many as there are things on the other side. The dashed lines show the fan-out. At organizational scale, this becomes unmanageable: nobody can see the whole picture, nobody owns the data in transit, and when something breaks at 2 a.m., the question 'whose problem is this?' rarely has a clear answer.</a:t>
             </a:r>
             <a:endParaRPr lang="en-US" dirty="0"/>
           </a:p>
@@ -1314,8 +1314,8 @@
           <a:p>
             <a:r>
               <a:rPr lang="en-US" dirty="0"/>
-              <a:t>The warehouse solved the truth problem that pipeline sprawl created. Instead of every consumer building its own understanding from raw pipeline output, everyone queries the same curated model. Schema-on-write is the defining characteristic — and it's a feature, not a bug: when two teams query 'total revenue last quarter,' they get the same number.
-The limitation is organizational, not technical. The central data team — sometimes called the BI team, the analytics engineering team, the data platform team — becomes the bottleneck in direct proportion to the organization's growth. They own all the data but understand none of the domains. When the logistics domain needs a new dimension, the request goes to the central team, who must learn enough about logistics to model it correctly, prioritize it against every other domain's requests, and coordinate the schema change without breaking downstream consumers. The analytical view is always stale because the ingestion pipelines run on a schedule, and the central team's capacity to model new data is the real constraint.</a:t>
+              <a:t>The warehouse solved the truth problem that pipeline sprawl created. Instead of every consumer building its own understanding from raw pipeline output, everyone queries the same curated model. Schema-on-write is the defining characteristic, and it's a feature, not a bug: when two teams query 'total revenue last quarter,' they get the same number.
+The limitation is organizational, not technical. The central data team (sometimes called the BI team, the analytics engineering team, the data platform team) becomes the bottleneck in direct proportion to the organization's growth. They own all the data but understand none of the domains. When the logistics domain needs a new dimension, the request goes to the central team, who must learn enough about logistics to model it correctly, prioritize it against every other domain's requests, and coordinate the schema change without breaking downstream consumers. The analytical view is always stale because the ingestion pipelines run on a schedule, and the central team's capacity to model new data is the real constraint.</a:t>
             </a:r>
             <a:endParaRPr lang="en-US" dirty="0"/>
           </a:p>
@@ -1403,8 +1403,8 @@
           <a:p>
             <a:r>
               <a:rPr lang="en-US" dirty="0"/>
-              <a:t>Walk the hub-and-spoke. Sources on the left — the same CRM, ERP, logs, events from before — all flowing into one centralized warehouse. The warehouse card in the center lists the defining characteristics: schema-on-write, star schemas, dimensional models, governed and structured. Consumers on the right: BI dashboards, reports, analysts — all querying the same governed store.
-Now look at the bottom: the Central Data Team card. This is the bottleneck. Every schema change, every new data source, every question funnels through this one team. The dashed arrows connecting them to the warehouse make the coupling visible. They own everything but understand none of the domains. The label says it plainly: 'the bottleneck a mesh exists to remove.' This team — not the technology — is what the mesh reorganizes.</a:t>
+              <a:t>Walk the hub-and-spoke. Sources on the left (the same CRM, ERP, logs, events from before), all flowing into one centralized warehouse. The warehouse card in the center lists the defining characteristics: schema-on-write, star schemas, dimensional models, governed and structured. Consumers on the right: BI dashboards, reports, analysts, all querying the same governed store.
+Now look at the bottom: the Central Data Team card. This is the bottleneck. Every schema change, every new data source, every question funnels through this one team. The dashed arrows connecting them to the warehouse make the coupling visible. They own everything but understand none of the domains. The label calls it out: 'the bottleneck a mesh exists to remove.' This team, not the technology, is what the mesh reorganizes.</a:t>
             </a:r>
             <a:endParaRPr lang="en-US" dirty="0"/>
           </a:p>
@@ -1492,9 +1492,9 @@
           <a:p>
             <a:r>
               <a:rPr lang="en-US" dirty="0"/>
-              <a:t>The lake solved the warehouse's most visible problem: format inflexibility. The warehouse can't handle Kafka events, Parquet files, images, sensor data. The lake can. At massive scale with cheap object storage, the lake makes it feasible to keep everything and decide later what's worth querying. That flexibility unlocked workloads — ML, unstructured analytics, exploratory data science — that warehouses were never built for.
+              <a:t>The lake solved the warehouse's most visible problem: format inflexibility. The warehouse can't handle Kafka events, Parquet files, images, sensor data. The lake can. At massive scale with cheap object storage, the lake makes it feasible to keep everything and decide later what's worth querying. That flexibility unlocked workloads (ML, unstructured analytics, exploratory data science) that warehouses were never built for.
 The zone model is how well-run lakes organize the data: raw (as-is from sources), curated (cleaned, typed), refined (modeled for consumption). The progression from raw to refined represents increasing transformation and decreasing generality.
-The limitation is governance. Without active curation, the lake becomes the 'data swamp' — undocumented datasets accumulate, nobody knows which version is authoritative, which datasets are stale, which duplicate each other. The curation effort needed to make a lake useful re-creates the warehouse's modeling work, just without the warehouse's enforcement mechanisms. And the organizational problem is unchanged: a central team still owns the lake.</a:t>
+The limitation is governance. Without active curation, the lake becomes the 'data swamp': undocumented datasets accumulate, nobody knows which version is authoritative, which datasets are stale, which duplicate each other. The curation effort needed to make a lake useful re-creates the warehouse's modeling work, just without the warehouse's enforcement mechanisms. And the organizational problem is unchanged: a central team still owns the lake.</a:t>
             </a:r>
             <a:endParaRPr lang="en-US" dirty="0"/>
           </a:p>
@@ -1582,8 +1582,8 @@
           <a:p>
             <a:r>
               <a:rPr lang="en-US" dirty="0"/>
-              <a:t>Walk the architecture. Heterogeneous sources on the left — structured, semi-structured, unstructured, streaming — this is the format flexibility the lake provides. The center shows the lake with its three zones in graduated shading: the raw/landing zone (data as-is), the curated zone (cleaned and typed), the refined zone (modeled and ready for consumption). Consumers on the right: analytics, ML/AI, reporting, ad-hoc queries — the diverse workloads the lake enables.
-Now the red callout at the bottom: 'Without governance, the lake becomes a swamp.' Data lands in the raw zone and never moves. Nobody knows what's valid, what's stale, what duplicates what. Schema-on-read means consumers discover structure at query time — if they can find the data at all. And the final line: the organizational bottleneck is unchanged. A central team still owns the bucket.</a:t>
+              <a:t>Walk the architecture. Heterogeneous sources on the left (structured, semi-structured, unstructured, streaming), this is the format flexibility the lake provides. The center shows the lake with its three zones in graduated shading: the raw/landing zone (data as-is), the curated zone (cleaned and typed), the refined zone (modeled and ready for consumption). Consumers on the right: analytics, ML/AI, reporting, ad-hoc queries, the diverse workloads the lake enables.
+Now the red callout at the bottom: 'Without governance, the lake becomes a swamp.' Data lands in the raw zone and never moves. Nobody knows what's valid, what's stale, what duplicates what. Schema-on-read means consumers discover structure at query time, if they can find the data at all. And the final line: the organizational bottleneck is unchanged. A central team still owns the bucket.</a:t>
             </a:r>
             <a:endParaRPr lang="en-US" dirty="0"/>
           </a:p>
@@ -1671,9 +1671,9 @@
           <a:p>
             <a:r>
               <a:rPr lang="en-US" dirty="0"/>
-              <a:t>This is the pivot slide — from what came before to what the mesh proposes. The key insight: all three prior patterns centralize data and hand ownership to a single team. The technology improves generation by generation — from bespoke pipelines, to a governed warehouse, to a flexible lake — but the organizational shape stays the same. One team at the center, receiving requests from every domain, owning data it did not produce, modeling concepts it does not deeply understand, scaling linearly while demands grow combinatorially.
-The mesh changes the axis: instead of a better center, decentralize ownership. Each domain owns its data as a product. A shared platform provides streaming, storage, registries, observability — so domains don't each build their own. Federated governance keeps the products interoperable — through platform-enforced standards, not review boards.
-Critical clarification: the mesh is not a replacement for warehouses or lakes. A domain may use a warehouse internally. The reorganization is about who owns the data — not which database to pick. An important caveat: the mesh earns its complexity in organizations with many domains, many consumers, and the maturity to operate federated ownership. For smaller teams, a well-run warehouse may be exactly right.</a:t>
+              <a:t>This is the pivot slide, from what came before to what the mesh proposes. The key insight: all three prior patterns centralize data and hand ownership to a single team. The technology improves generation by generation, from bespoke pipelines, to a governed warehouse, to a flexible lake, but the organizational shape stays the same. One team at the center, receiving requests from every domain, owning data it did not produce, modeling concepts it does not deeply understand, scaling linearly while demands grow combinatorially.
+The mesh changes the axis: instead of a better center, decentralize ownership. Each domain owns its data as a product. A shared platform provides streaming, storage, registries, observability, so domains don't each build their own. Federated governance keeps the products interoperable, through platform-enforced standards, not review boards.
+Critical clarification: the mesh is not a replacement for warehouses or lakes. A domain may use a warehouse internally. The reorganization is about who owns the data, not which database to pick. An important caveat: the mesh's added complexity pays off in organizations with many domains, many consumers, and the maturity to operate federated ownership. For smaller teams, a well-run warehouse may be exactly right.</a:t>
             </a:r>
             <a:endParaRPr lang="en-US" dirty="0"/>
           </a:p>
@@ -2183,7 +2183,7 @@
                 <a:ea typeface="Red Hat Text" pitchFamily="34" charset="-122"/>
                 <a:cs typeface="Red Hat Text" pitchFamily="34" charset="-120"/>
               </a:rPr>
-              <a:t>From pipelines and warehouses to decentralized, domain-owned data products — the landscape, the principles, and why the mesh is a different kind of answer.</a:t>
+              <a:t>From pipelines and warehouses to decentralized, domain-owned data products: the landscape, the principles, and why the mesh is a different kind of answer.</a:t>
             </a:r>
             <a:endParaRPr lang="en-US" sz="1700" dirty="0"/>
           </a:p>
@@ -2395,7 +2395,7 @@
                 <a:ea typeface="Overpass SemiBold" pitchFamily="34" charset="-122"/>
                 <a:cs typeface="Overpass SemiBold" pitchFamily="34" charset="-120"/>
               </a:rPr>
-              <a:t>The mesh — decentralized, domain-owned data products</a:t>
+              <a:t>The mesh: decentralized, domain-owned data products</a:t>
             </a:r>
             <a:endParaRPr lang="en-US" sz="3000" dirty="0"/>
           </a:p>
@@ -2458,7 +2458,7 @@
                 <a:ea typeface="Red Hat Text" pitchFamily="34" charset="-122"/>
                 <a:cs typeface="Red Hat Text" pitchFamily="34" charset="-120"/>
               </a:rPr>
-              <a:t>Each domain owns its data as a product, on a shared platform under federated governance — the organizational answer.</a:t>
+              <a:t>Each domain owns its data as a product, on a shared platform under federated governance: the organizational answer.</a:t>
             </a:r>
             <a:endParaRPr lang="en-US" sz="1250" dirty="0"/>
           </a:p>
@@ -2631,7 +2631,7 @@
                 <a:ea typeface="Overpass SemiBold" pitchFamily="34" charset="-122"/>
                 <a:cs typeface="Overpass SemiBold" pitchFamily="34" charset="-120"/>
               </a:rPr>
-              <a:t>The evolution — from pipelines to mesh</a:t>
+              <a:t>The evolution: from pipelines to mesh</a:t>
             </a:r>
             <a:endParaRPr lang="en-US" sz="3000" dirty="0"/>
           </a:p>
@@ -2910,7 +2910,7 @@
                 <a:ea typeface="Red Hat Text" pitchFamily="34" charset="-122"/>
                 <a:cs typeface="Red Hat Text" pitchFamily="34" charset="-120"/>
               </a:rPr>
-              <a:t>The choice depends on scale, data landscape, and where the bottleneck sits — not on which pattern is newest.</a:t>
+              <a:t>The choice depends on scale, data landscape, and where the bottleneck sits, not on which pattern is newest.</a:t>
             </a:r>
             <a:endParaRPr lang="en-US" sz="1600" dirty="0"/>
           </a:p>
@@ -2998,7 +2998,7 @@
                 <a:ea typeface="Red Hat Text" pitchFamily="34" charset="-122"/>
                 <a:cs typeface="Red Hat Text" pitchFamily="34" charset="-120"/>
               </a:rPr>
-              <a:t>The organization needs a governed analytical view — BI, reporting, structured decisions — and a central team has the capacity to curate it. The bottleneck is the absence of a single source of truth.</a:t>
+              <a:t>The organization needs a governed analytical view (BI, reporting, structured decisions) and a central team has the capacity to curate it. The bottleneck is the absence of a single source of truth.</a:t>
             </a:r>
             <a:endParaRPr lang="en-US" sz="1600" dirty="0"/>
           </a:p>
@@ -3086,7 +3086,7 @@
                 <a:ea typeface="Red Hat Text" pitchFamily="34" charset="-122"/>
                 <a:cs typeface="Red Hat Text" pitchFamily="34" charset="-120"/>
               </a:rPr>
-              <a:t>Many domains, many consumers, and the central team has become the constraint. The bottleneck is organizational — who owns what — not technical.</a:t>
+              <a:t>Many domains, many consumers, and the central team has become the constraint. The bottleneck is organizational (who owns what), not technical.</a:t>
             </a:r>
             <a:endParaRPr lang="en-US" sz="1600" dirty="0"/>
           </a:p>
@@ -3236,7 +3236,7 @@
                 <a:ea typeface="Overpass SemiBold" pitchFamily="34" charset="-122"/>
                 <a:cs typeface="Overpass SemiBold" pitchFamily="34" charset="-120"/>
               </a:rPr>
-              <a:t>The mesh is the network of products —</a:t>
+              <a:t>The mesh is the network of products,</a:t>
             </a:r>
             <a:endParaRPr lang="en-US" sz="2800" dirty="0"/>
           </a:p>
@@ -3978,7 +3978,7 @@
                 <a:ea typeface="Red Hat Text" pitchFamily="34" charset="-122"/>
                 <a:cs typeface="Red Hat Text" pitchFamily="34" charset="-120"/>
               </a:rPr>
-              <a:t>Four data architectures — what each pattern solves and the limitation it leaves behind.</a:t>
+              <a:t>Four data architectures: what each pattern solves and the limitation it leaves behind.</a:t>
             </a:r>
             <a:endParaRPr lang="en-US" sz="1600" dirty="0"/>
           </a:p>
@@ -4112,7 +4112,7 @@
                 <a:ea typeface="Overpass SemiBold" pitchFamily="34" charset="-122"/>
                 <a:cs typeface="Overpass SemiBold" pitchFamily="34" charset="-120"/>
               </a:rPr>
-              <a:t>Data pipelines — the plumbing</a:t>
+              <a:t>Data pipelines: the plumbing</a:t>
             </a:r>
             <a:endParaRPr lang="en-US" sz="3000" dirty="0"/>
           </a:p>
@@ -4176,7 +4176,7 @@
                 <a:ea typeface="Red Hat Text" pitchFamily="34" charset="-122"/>
                 <a:cs typeface="Red Hat Text" pitchFamily="34" charset="-120"/>
               </a:rPr>
-              <a:t>A data pipeline is that something — a sequence of steps that extracts data from a source, transforms it, and loads it into a target store.</a:t>
+              <a:t>A data pipeline is that something: a sequence of steps that extracts data from a source, transforms it, and loads it into a target store.</a:t>
             </a:r>
             <a:endParaRPr lang="en-US" sz="1600" dirty="0"/>
           </a:p>
@@ -4285,7 +4285,7 @@
                 <a:ea typeface="Red Hat Text" pitchFamily="34" charset="-122"/>
                 <a:cs typeface="Red Hat Text" pitchFamily="34" charset="-120"/>
               </a:rPr>
-              <a:t>Each source-destination pair needs its own pipeline. The total grows as the product of sources and destinations, not the sum. Nobody 'owns' the data flowing through a pipeline — the pipeline is plumbing, not a product.</a:t>
+              <a:t>Each source-destination pair needs its own pipeline. The total grows as the product of sources and destinations, not the sum. Nobody 'owns' the data flowing through a pipeline; the pipeline is plumbing, not a product.</a:t>
             </a:r>
             <a:endParaRPr lang="en-US" sz="1600" dirty="0"/>
           </a:p>
@@ -4458,7 +4458,7 @@
                 <a:ea typeface="Overpass SemiBold" pitchFamily="34" charset="-122"/>
                 <a:cs typeface="Overpass SemiBold" pitchFamily="34" charset="-120"/>
               </a:rPr>
-              <a:t>Pipeline architecture — linear, bespoke, multiplying</a:t>
+              <a:t>Pipeline architecture: linear, bespoke, multiplying</a:t>
             </a:r>
             <a:endParaRPr lang="en-US" sz="3000" dirty="0"/>
           </a:p>
@@ -4694,7 +4694,7 @@
                 <a:ea typeface="Overpass SemiBold" pitchFamily="34" charset="-122"/>
                 <a:cs typeface="Overpass SemiBold" pitchFamily="34" charset="-120"/>
               </a:rPr>
-              <a:t>Data warehouses — the single source of truth</a:t>
+              <a:t>Data warehouses: the single source of truth</a:t>
             </a:r>
             <a:endParaRPr lang="en-US" sz="3000" dirty="0"/>
           </a:p>
@@ -4758,7 +4758,7 @@
                 <a:ea typeface="Red Hat Text" pitchFamily="34" charset="-122"/>
                 <a:cs typeface="Red Hat Text" pitchFamily="34" charset="-120"/>
               </a:rPr>
-              <a:t>Star schemas, fact tables, dimension tables — all optimized for the aggregations and joins that BI tools need.</a:t>
+              <a:t>Star schemas, fact tables, dimension tables: all optimized for the aggregations and joins that BI tools need.</a:t>
             </a:r>
             <a:endParaRPr lang="en-US" sz="1600" dirty="0"/>
           </a:p>
@@ -4867,7 +4867,7 @@
                 <a:ea typeface="Red Hat Text" pitchFamily="34" charset="-122"/>
                 <a:cs typeface="Red Hat Text" pitchFamily="34" charset="-120"/>
               </a:rPr>
-              <a:t>As the organization grows, the central team processes more requests than it can understand — the queue becomes the bottleneck.</a:t>
+              <a:t>As the organization grows, the central team processes more requests than it can understand; the queue becomes the bottleneck.</a:t>
             </a:r>
             <a:endParaRPr lang="en-US" sz="1600" dirty="0"/>
           </a:p>
@@ -5040,7 +5040,7 @@
                 <a:ea typeface="Overpass SemiBold" pitchFamily="34" charset="-122"/>
                 <a:cs typeface="Overpass SemiBold" pitchFamily="34" charset="-120"/>
               </a:rPr>
-              <a:t>Warehouse architecture — many sources, one team, one store</a:t>
+              <a:t>Warehouse architecture: many sources, one team, one store</a:t>
             </a:r>
             <a:endParaRPr lang="en-US" sz="3000" dirty="0"/>
           </a:p>
@@ -5103,7 +5103,7 @@
                 <a:ea typeface="Red Hat Text" pitchFamily="34" charset="-122"/>
                 <a:cs typeface="Red Hat Text" pitchFamily="34" charset="-120"/>
               </a:rPr>
-              <a:t>Many sources, one warehouse, one team — the single source of truth, and the single point of contention.</a:t>
+              <a:t>Many sources, one warehouse, one team: the single source of truth, and the single point of contention.</a:t>
             </a:r>
             <a:endParaRPr lang="en-US" sz="1250" dirty="0"/>
           </a:p>
@@ -5276,7 +5276,7 @@
                 <a:ea typeface="Overpass SemiBold" pitchFamily="34" charset="-122"/>
                 <a:cs typeface="Overpass SemiBold" pitchFamily="34" charset="-120"/>
               </a:rPr>
-              <a:t>Data lakes — accept everything, sort it out later</a:t>
+              <a:t>Data lakes: accept everything, sort it out later</a:t>
             </a:r>
             <a:endParaRPr lang="en-US" sz="3000" dirty="0"/>
           </a:p>
@@ -5319,7 +5319,7 @@
                 <a:ea typeface="Red Hat Text" pitchFamily="34" charset="-122"/>
                 <a:cs typeface="Red Hat Text" pitchFamily="34" charset="-120"/>
               </a:rPr>
-              <a:t>A data lake accepts data in any format — structured, semi-structured, unstructured, streaming — and defers schema decisions to the point of consumption. This is schema-on-read.</a:t>
+              <a:t>A data lake accepts data in any format (structured, semi-structured, unstructured, streaming) and defers schema decisions to the point of consumption. This is schema-on-read.</a:t>
             </a:r>
             <a:endParaRPr lang="en-US" sz="1600" dirty="0"/>
           </a:p>
@@ -5451,7 +5451,7 @@
                 <a:ea typeface="Red Hat Text" pitchFamily="34" charset="-122"/>
                 <a:cs typeface="Red Hat Text" pitchFamily="34" charset="-120"/>
               </a:rPr>
-              <a:t>Without governance, the lake becomes a data swamp — undocumented, stale, duplicated datasets nobody trusts. The curation effort re-creates warehouse work, and a central team still owns the bucket.</a:t>
+              <a:t>Without governance, the lake becomes a data swamp: undocumented, stale, duplicated datasets nobody trusts. The curation effort re-creates warehouse work, and a central team still owns the bucket.</a:t>
             </a:r>
             <a:endParaRPr lang="en-US" sz="1600" dirty="0"/>
           </a:p>
@@ -5624,7 +5624,7 @@
                 <a:ea typeface="Overpass SemiBold" pitchFamily="34" charset="-122"/>
                 <a:cs typeface="Overpass SemiBold" pitchFamily="34" charset="-120"/>
               </a:rPr>
-              <a:t>Lake architecture — zones, flexibility, and the swamp risk</a:t>
+              <a:t>Lake architecture: zones, flexibility, and the swamp risk</a:t>
             </a:r>
             <a:endParaRPr lang="en-US" sz="3000" dirty="0"/>
           </a:p>
@@ -5687,7 +5687,7 @@
                 <a:ea typeface="Red Hat Text" pitchFamily="34" charset="-122"/>
                 <a:cs typeface="Red Hat Text" pitchFamily="34" charset="-120"/>
               </a:rPr>
-              <a:t>Raw, curated, refined — flexible on the way in, but without governance the lake becomes a swamp, and the central-team bottleneck remains.</a:t>
+              <a:t>Raw, curated, refined: flexible on the way in, but without governance the lake becomes a swamp, and the central-team bottleneck remains.</a:t>
             </a:r>
             <a:endParaRPr lang="en-US" sz="1250" dirty="0"/>
           </a:p>
@@ -5860,7 +5860,7 @@
                 <a:ea typeface="Overpass SemiBold" pitchFamily="34" charset="-122"/>
                 <a:cs typeface="Overpass SemiBold" pitchFamily="34" charset="-120"/>
               </a:rPr>
-              <a:t>Data mesh — a different kind of answer</a:t>
+              <a:t>Data mesh: a different kind of answer</a:t>
             </a:r>
             <a:endParaRPr lang="en-US" sz="3000" dirty="0"/>
           </a:p>
@@ -5903,7 +5903,7 @@
                 <a:ea typeface="Red Hat Text" pitchFamily="34" charset="-122"/>
                 <a:cs typeface="Red Hat Text" pitchFamily="34" charset="-120"/>
               </a:rPr>
-              <a:t>All three patterns — pipelines, warehouses, lakes — centralize data and hand ownership to a single team. The technology improves; the organizational shape stays the same: one team at the center.</a:t>
+              <a:t>All three patterns (pipelines, warehouses, lakes) centralize data and hand ownership to a single team. The technology improves; the organizational shape stays the same: one team at the center.</a:t>
             </a:r>
             <a:endParaRPr lang="en-US" sz="1600" dirty="0"/>
           </a:p>
@@ -5947,7 +5947,7 @@
                 <a:ea typeface="Red Hat Text" pitchFamily="34" charset="-122"/>
                 <a:cs typeface="Red Hat Text" pitchFamily="34" charset="-120"/>
               </a:rPr>
-              <a:t>Instead of building a better center, decentralize ownership to the domain teams that produce the data. Each domain owns its data as a product — discoverable, addressable, trustworthy, self-describing.</a:t>
+              <a:t>Instead of building a better center, decentralize ownership to the domain teams that produce the data. Each domain owns its data as a product: discoverable, addressable, trustworthy, self-describing.</a:t>
             </a:r>
             <a:endParaRPr lang="en-US" sz="1600" dirty="0"/>
           </a:p>
@@ -6033,7 +6033,7 @@
                 <a:ea typeface="Red Hat Text" pitchFamily="34" charset="-122"/>
                 <a:cs typeface="Red Hat Text" pitchFamily="34" charset="-120"/>
               </a:rPr>
-              <a:t>The mesh earns its complexity in organizations with many domains, many consumers, and the maturity to operate federated ownership.</a:t>
+              <a:t>The mesh's added complexity pays off in organizations with many domains, many consumers, and the maturity to operate federated ownership.</a:t>
             </a:r>
             <a:endParaRPr lang="en-US" sz="1600" dirty="0"/>
           </a:p>

</xml_diff>

<commit_message>
docs(deck): Red Hat Display titles on the data-mesh decks
Replace the Overpass SemiBold heading font token with Red Hat Display in
both pptxgenjs sources (The Data Mesh 101, Data Mesh on OpenShift) and
rebuild; body (Red Hat Text) and code (Red Hat Mono) fonts are unchanged.
</commit_message>
<xml_diff>
--- a/presentation/data-mesh-101/The_Data_Mesh_101.pptx
+++ b/presentation/data-mesh-101/The_Data_Mesh_101.pptx
@@ -2098,9 +2098,9 @@
                 <a:solidFill>
                   <a:srgbClr val="EE0000"/>
                 </a:solidFill>
-                <a:latin typeface="Overpass SemiBold" pitchFamily="34" charset="0"/>
-                <a:ea typeface="Overpass SemiBold" pitchFamily="34" charset="-122"/>
-                <a:cs typeface="Overpass SemiBold" pitchFamily="34" charset="-120"/>
+                <a:latin typeface="Red Hat Display" pitchFamily="34" charset="0"/>
+                <a:ea typeface="Red Hat Display" pitchFamily="34" charset="-122"/>
+                <a:cs typeface="Red Hat Display" pitchFamily="34" charset="-120"/>
               </a:rPr>
               <a:t>DATA MESH · PRIMER</a:t>
             </a:r>
@@ -2140,9 +2140,9 @@
                 <a:solidFill>
                   <a:srgbClr val="151515"/>
                 </a:solidFill>
-                <a:latin typeface="Overpass SemiBold" pitchFamily="34" charset="0"/>
-                <a:ea typeface="Overpass SemiBold" pitchFamily="34" charset="-122"/>
-                <a:cs typeface="Overpass SemiBold" pitchFamily="34" charset="-120"/>
+                <a:latin typeface="Red Hat Display" pitchFamily="34" charset="0"/>
+                <a:ea typeface="Red Hat Display" pitchFamily="34" charset="-122"/>
+                <a:cs typeface="Red Hat Display" pitchFamily="34" charset="-120"/>
               </a:rPr>
               <a:t>The Data Mesh</a:t>
             </a:r>
@@ -2352,9 +2352,9 @@
                 <a:solidFill>
                   <a:srgbClr val="EE0000"/>
                 </a:solidFill>
-                <a:latin typeface="Overpass SemiBold" pitchFamily="34" charset="0"/>
-                <a:ea typeface="Overpass SemiBold" pitchFamily="34" charset="-122"/>
-                <a:cs typeface="Overpass SemiBold" pitchFamily="34" charset="-120"/>
+                <a:latin typeface="Red Hat Display" pitchFamily="34" charset="0"/>
+                <a:ea typeface="Red Hat Display" pitchFamily="34" charset="-122"/>
+                <a:cs typeface="Red Hat Display" pitchFamily="34" charset="-120"/>
               </a:rPr>
               <a:t>DATA ARCHITECTURES</a:t>
             </a:r>
@@ -2391,9 +2391,9 @@
                 <a:solidFill>
                   <a:srgbClr val="151515"/>
                 </a:solidFill>
-                <a:latin typeface="Overpass SemiBold" pitchFamily="34" charset="0"/>
-                <a:ea typeface="Overpass SemiBold" pitchFamily="34" charset="-122"/>
-                <a:cs typeface="Overpass SemiBold" pitchFamily="34" charset="-120"/>
+                <a:latin typeface="Red Hat Display" pitchFamily="34" charset="0"/>
+                <a:ea typeface="Red Hat Display" pitchFamily="34" charset="-122"/>
+                <a:cs typeface="Red Hat Display" pitchFamily="34" charset="-120"/>
               </a:rPr>
               <a:t>The mesh: decentralized, domain-owned data products</a:t>
             </a:r>
@@ -2588,9 +2588,9 @@
                 <a:solidFill>
                   <a:srgbClr val="EE0000"/>
                 </a:solidFill>
-                <a:latin typeface="Overpass SemiBold" pitchFamily="34" charset="0"/>
-                <a:ea typeface="Overpass SemiBold" pitchFamily="34" charset="-122"/>
-                <a:cs typeface="Overpass SemiBold" pitchFamily="34" charset="-120"/>
+                <a:latin typeface="Red Hat Display" pitchFamily="34" charset="0"/>
+                <a:ea typeface="Red Hat Display" pitchFamily="34" charset="-122"/>
+                <a:cs typeface="Red Hat Display" pitchFamily="34" charset="-120"/>
               </a:rPr>
               <a:t>DATA ARCHITECTURES</a:t>
             </a:r>
@@ -2627,9 +2627,9 @@
                 <a:solidFill>
                   <a:srgbClr val="151515"/>
                 </a:solidFill>
-                <a:latin typeface="Overpass SemiBold" pitchFamily="34" charset="0"/>
-                <a:ea typeface="Overpass SemiBold" pitchFamily="34" charset="-122"/>
-                <a:cs typeface="Overpass SemiBold" pitchFamily="34" charset="-120"/>
+                <a:latin typeface="Red Hat Display" pitchFamily="34" charset="0"/>
+                <a:ea typeface="Red Hat Display" pitchFamily="34" charset="-122"/>
+                <a:cs typeface="Red Hat Display" pitchFamily="34" charset="-120"/>
               </a:rPr>
               <a:t>The evolution: from pipelines to mesh</a:t>
             </a:r>
@@ -2824,9 +2824,9 @@
                 <a:solidFill>
                   <a:srgbClr val="EE0000"/>
                 </a:solidFill>
-                <a:latin typeface="Overpass SemiBold" pitchFamily="34" charset="0"/>
-                <a:ea typeface="Overpass SemiBold" pitchFamily="34" charset="-122"/>
-                <a:cs typeface="Overpass SemiBold" pitchFamily="34" charset="-120"/>
+                <a:latin typeface="Red Hat Display" pitchFamily="34" charset="0"/>
+                <a:ea typeface="Red Hat Display" pitchFamily="34" charset="-122"/>
+                <a:cs typeface="Red Hat Display" pitchFamily="34" charset="-120"/>
               </a:rPr>
               <a:t>DATA ARCHITECTURES</a:t>
             </a:r>
@@ -2863,9 +2863,9 @@
                 <a:solidFill>
                   <a:srgbClr val="151515"/>
                 </a:solidFill>
-                <a:latin typeface="Overpass SemiBold" pitchFamily="34" charset="0"/>
-                <a:ea typeface="Overpass SemiBold" pitchFamily="34" charset="-122"/>
-                <a:cs typeface="Overpass SemiBold" pitchFamily="34" charset="-120"/>
+                <a:latin typeface="Red Hat Display" pitchFamily="34" charset="0"/>
+                <a:ea typeface="Red Hat Display" pitchFamily="34" charset="-122"/>
+                <a:cs typeface="Red Hat Display" pitchFamily="34" charset="-120"/>
               </a:rPr>
               <a:t>When each pattern fits</a:t>
             </a:r>
@@ -2929,9 +2929,9 @@
                 <a:solidFill>
                   <a:srgbClr val="151515"/>
                 </a:solidFill>
-                <a:latin typeface="Overpass SemiBold" pitchFamily="34" charset="0"/>
-                <a:ea typeface="Overpass SemiBold" pitchFamily="34" charset="-122"/>
-                <a:cs typeface="Overpass SemiBold" pitchFamily="34" charset="-120"/>
+                <a:latin typeface="Red Hat Display" pitchFamily="34" charset="0"/>
+                <a:ea typeface="Red Hat Display" pitchFamily="34" charset="-122"/>
+                <a:cs typeface="Red Hat Display" pitchFamily="34" charset="-120"/>
               </a:rPr>
               <a:t>Pipelines</a:t>
             </a:r>
@@ -2973,9 +2973,9 @@
                 <a:solidFill>
                   <a:srgbClr val="151515"/>
                 </a:solidFill>
-                <a:latin typeface="Overpass SemiBold" pitchFamily="34" charset="0"/>
-                <a:ea typeface="Overpass SemiBold" pitchFamily="34" charset="-122"/>
-                <a:cs typeface="Overpass SemiBold" pitchFamily="34" charset="-120"/>
+                <a:latin typeface="Red Hat Display" pitchFamily="34" charset="0"/>
+                <a:ea typeface="Red Hat Display" pitchFamily="34" charset="-122"/>
+                <a:cs typeface="Red Hat Display" pitchFamily="34" charset="-120"/>
               </a:rPr>
               <a:t>Warehouse</a:t>
             </a:r>
@@ -3017,9 +3017,9 @@
                 <a:solidFill>
                   <a:srgbClr val="151515"/>
                 </a:solidFill>
-                <a:latin typeface="Overpass SemiBold" pitchFamily="34" charset="0"/>
-                <a:ea typeface="Overpass SemiBold" pitchFamily="34" charset="-122"/>
-                <a:cs typeface="Overpass SemiBold" pitchFamily="34" charset="-120"/>
+                <a:latin typeface="Red Hat Display" pitchFamily="34" charset="0"/>
+                <a:ea typeface="Red Hat Display" pitchFamily="34" charset="-122"/>
+                <a:cs typeface="Red Hat Display" pitchFamily="34" charset="-120"/>
               </a:rPr>
               <a:t>Lake</a:t>
             </a:r>
@@ -3061,9 +3061,9 @@
                 <a:solidFill>
                   <a:srgbClr val="151515"/>
                 </a:solidFill>
-                <a:latin typeface="Overpass SemiBold" pitchFamily="34" charset="0"/>
-                <a:ea typeface="Overpass SemiBold" pitchFamily="34" charset="-122"/>
-                <a:cs typeface="Overpass SemiBold" pitchFamily="34" charset="-120"/>
+                <a:latin typeface="Red Hat Display" pitchFamily="34" charset="0"/>
+                <a:ea typeface="Red Hat Display" pitchFamily="34" charset="-122"/>
+                <a:cs typeface="Red Hat Display" pitchFamily="34" charset="-120"/>
               </a:rPr>
               <a:t>Mesh</a:t>
             </a:r>
@@ -3232,9 +3232,9 @@
                 <a:solidFill>
                   <a:srgbClr val="FFFFFF"/>
                 </a:solidFill>
-                <a:latin typeface="Overpass SemiBold" pitchFamily="34" charset="0"/>
-                <a:ea typeface="Overpass SemiBold" pitchFamily="34" charset="-122"/>
-                <a:cs typeface="Overpass SemiBold" pitchFamily="34" charset="-120"/>
+                <a:latin typeface="Red Hat Display" pitchFamily="34" charset="0"/>
+                <a:ea typeface="Red Hat Display" pitchFamily="34" charset="-122"/>
+                <a:cs typeface="Red Hat Display" pitchFamily="34" charset="-120"/>
               </a:rPr>
               <a:t>The mesh is the network of products,</a:t>
             </a:r>
@@ -3271,9 +3271,9 @@
                 <a:solidFill>
                   <a:srgbClr val="FFD9D9"/>
                 </a:solidFill>
-                <a:latin typeface="Overpass SemiBold" pitchFamily="34" charset="0"/>
-                <a:ea typeface="Overpass SemiBold" pitchFamily="34" charset="-122"/>
-                <a:cs typeface="Overpass SemiBold" pitchFamily="34" charset="-120"/>
+                <a:latin typeface="Red Hat Display" pitchFamily="34" charset="0"/>
+                <a:ea typeface="Red Hat Display" pitchFamily="34" charset="-122"/>
+                <a:cs typeface="Red Hat Display" pitchFamily="34" charset="-120"/>
               </a:rPr>
               <a:t>plus the platform and standards</a:t>
             </a:r>
@@ -3288,9 +3288,9 @@
                 <a:solidFill>
                   <a:srgbClr val="FFD9D9"/>
                 </a:solidFill>
-                <a:latin typeface="Overpass SemiBold" pitchFamily="34" charset="0"/>
-                <a:ea typeface="Overpass SemiBold" pitchFamily="34" charset="-122"/>
-                <a:cs typeface="Overpass SemiBold" pitchFamily="34" charset="-120"/>
+                <a:latin typeface="Red Hat Display" pitchFamily="34" charset="0"/>
+                <a:ea typeface="Red Hat Display" pitchFamily="34" charset="-122"/>
+                <a:cs typeface="Red Hat Display" pitchFamily="34" charset="-120"/>
               </a:rPr>
               <a:t>that let them interoperate.</a:t>
             </a:r>
@@ -3485,9 +3485,9 @@
                 <a:solidFill>
                   <a:srgbClr val="EE0000"/>
                 </a:solidFill>
-                <a:latin typeface="Overpass SemiBold" pitchFamily="34" charset="0"/>
-                <a:ea typeface="Overpass SemiBold" pitchFamily="34" charset="-122"/>
-                <a:cs typeface="Overpass SemiBold" pitchFamily="34" charset="-120"/>
+                <a:latin typeface="Red Hat Display" pitchFamily="34" charset="0"/>
+                <a:ea typeface="Red Hat Display" pitchFamily="34" charset="-122"/>
+                <a:cs typeface="Red Hat Display" pitchFamily="34" charset="-120"/>
               </a:rPr>
               <a:t>SCAN TO EXPLORE</a:t>
             </a:r>
@@ -3524,9 +3524,9 @@
                 <a:solidFill>
                   <a:srgbClr val="151515"/>
                 </a:solidFill>
-                <a:latin typeface="Overpass SemiBold" pitchFamily="34" charset="0"/>
-                <a:ea typeface="Overpass SemiBold" pitchFamily="34" charset="-122"/>
-                <a:cs typeface="Overpass SemiBold" pitchFamily="34" charset="-120"/>
+                <a:latin typeface="Red Hat Display" pitchFamily="34" charset="0"/>
+                <a:ea typeface="Red Hat Display" pitchFamily="34" charset="-122"/>
+                <a:cs typeface="Red Hat Display" pitchFamily="34" charset="-120"/>
               </a:rPr>
               <a:t>Take it with you</a:t>
             </a:r>
@@ -3587,9 +3587,9 @@
                 <a:solidFill>
                   <a:srgbClr val="151515"/>
                 </a:solidFill>
-                <a:latin typeface="Overpass SemiBold" pitchFamily="34" charset="0"/>
-                <a:ea typeface="Overpass SemiBold" pitchFamily="34" charset="-122"/>
-                <a:cs typeface="Overpass SemiBold" pitchFamily="34" charset="-120"/>
+                <a:latin typeface="Red Hat Display" pitchFamily="34" charset="0"/>
+                <a:ea typeface="Red Hat Display" pitchFamily="34" charset="-122"/>
+                <a:cs typeface="Red Hat Display" pitchFamily="34" charset="-120"/>
               </a:rPr>
               <a:t>The reference architecture</a:t>
             </a:r>
@@ -3728,9 +3728,9 @@
                 <a:solidFill>
                   <a:srgbClr val="151515"/>
                 </a:solidFill>
-                <a:latin typeface="Overpass SemiBold" pitchFamily="34" charset="0"/>
-                <a:ea typeface="Overpass SemiBold" pitchFamily="34" charset="-122"/>
-                <a:cs typeface="Overpass SemiBold" pitchFamily="34" charset="-120"/>
+                <a:latin typeface="Red Hat Display" pitchFamily="34" charset="0"/>
+                <a:ea typeface="Red Hat Display" pitchFamily="34" charset="-122"/>
+                <a:cs typeface="Red Hat Display" pitchFamily="34" charset="-120"/>
               </a:rPr>
               <a:t>Workshops &amp; Tutorials</a:t>
             </a:r>
@@ -3935,9 +3935,9 @@
                 <a:solidFill>
                   <a:srgbClr val="FFFFFF"/>
                 </a:solidFill>
-                <a:latin typeface="Overpass SemiBold" pitchFamily="34" charset="0"/>
-                <a:ea typeface="Overpass SemiBold" pitchFamily="34" charset="-122"/>
-                <a:cs typeface="Overpass SemiBold" pitchFamily="34" charset="-120"/>
+                <a:latin typeface="Red Hat Display" pitchFamily="34" charset="0"/>
+                <a:ea typeface="Red Hat Display" pitchFamily="34" charset="-122"/>
+                <a:cs typeface="Red Hat Display" pitchFamily="34" charset="-120"/>
               </a:rPr>
               <a:t>The landscape</a:t>
             </a:r>
@@ -4069,9 +4069,9 @@
                 <a:solidFill>
                   <a:srgbClr val="EE0000"/>
                 </a:solidFill>
-                <a:latin typeface="Overpass SemiBold" pitchFamily="34" charset="0"/>
-                <a:ea typeface="Overpass SemiBold" pitchFamily="34" charset="-122"/>
-                <a:cs typeface="Overpass SemiBold" pitchFamily="34" charset="-120"/>
+                <a:latin typeface="Red Hat Display" pitchFamily="34" charset="0"/>
+                <a:ea typeface="Red Hat Display" pitchFamily="34" charset="-122"/>
+                <a:cs typeface="Red Hat Display" pitchFamily="34" charset="-120"/>
               </a:rPr>
               <a:t>DATA ARCHITECTURES</a:t>
             </a:r>
@@ -4108,9 +4108,9 @@
                 <a:solidFill>
                   <a:srgbClr val="151515"/>
                 </a:solidFill>
-                <a:latin typeface="Overpass SemiBold" pitchFamily="34" charset="0"/>
-                <a:ea typeface="Overpass SemiBold" pitchFamily="34" charset="-122"/>
-                <a:cs typeface="Overpass SemiBold" pitchFamily="34" charset="-120"/>
+                <a:latin typeface="Red Hat Display" pitchFamily="34" charset="0"/>
+                <a:ea typeface="Red Hat Display" pitchFamily="34" charset="-122"/>
+                <a:cs typeface="Red Hat Display" pitchFamily="34" charset="-120"/>
               </a:rPr>
               <a:t>Data pipelines: the plumbing</a:t>
             </a:r>
@@ -4195,9 +4195,9 @@
                 <a:solidFill>
                   <a:srgbClr val="151515"/>
                 </a:solidFill>
-                <a:latin typeface="Overpass SemiBold" pitchFamily="34" charset="0"/>
-                <a:ea typeface="Overpass SemiBold" pitchFamily="34" charset="-122"/>
-                <a:cs typeface="Overpass SemiBold" pitchFamily="34" charset="-120"/>
+                <a:latin typeface="Red Hat Display" pitchFamily="34" charset="0"/>
+                <a:ea typeface="Red Hat Display" pitchFamily="34" charset="-122"/>
+                <a:cs typeface="Red Hat Display" pitchFamily="34" charset="-120"/>
               </a:rPr>
               <a:t>ETL vs. ELT</a:t>
             </a:r>
@@ -4260,9 +4260,9 @@
                 <a:solidFill>
                   <a:srgbClr val="151515"/>
                 </a:solidFill>
-                <a:latin typeface="Overpass SemiBold" pitchFamily="34" charset="0"/>
-                <a:ea typeface="Overpass SemiBold" pitchFamily="34" charset="-122"/>
-                <a:cs typeface="Overpass SemiBold" pitchFamily="34" charset="-120"/>
+                <a:latin typeface="Red Hat Display" pitchFamily="34" charset="0"/>
+                <a:ea typeface="Red Hat Display" pitchFamily="34" charset="-122"/>
+                <a:cs typeface="Red Hat Display" pitchFamily="34" charset="-120"/>
               </a:rPr>
               <a:t>The limitation: pipeline sprawl</a:t>
             </a:r>
@@ -4415,9 +4415,9 @@
                 <a:solidFill>
                   <a:srgbClr val="EE0000"/>
                 </a:solidFill>
-                <a:latin typeface="Overpass SemiBold" pitchFamily="34" charset="0"/>
-                <a:ea typeface="Overpass SemiBold" pitchFamily="34" charset="-122"/>
-                <a:cs typeface="Overpass SemiBold" pitchFamily="34" charset="-120"/>
+                <a:latin typeface="Red Hat Display" pitchFamily="34" charset="0"/>
+                <a:ea typeface="Red Hat Display" pitchFamily="34" charset="-122"/>
+                <a:cs typeface="Red Hat Display" pitchFamily="34" charset="-120"/>
               </a:rPr>
               <a:t>DATA ARCHITECTURES</a:t>
             </a:r>
@@ -4454,9 +4454,9 @@
                 <a:solidFill>
                   <a:srgbClr val="151515"/>
                 </a:solidFill>
-                <a:latin typeface="Overpass SemiBold" pitchFamily="34" charset="0"/>
-                <a:ea typeface="Overpass SemiBold" pitchFamily="34" charset="-122"/>
-                <a:cs typeface="Overpass SemiBold" pitchFamily="34" charset="-120"/>
+                <a:latin typeface="Red Hat Display" pitchFamily="34" charset="0"/>
+                <a:ea typeface="Red Hat Display" pitchFamily="34" charset="-122"/>
+                <a:cs typeface="Red Hat Display" pitchFamily="34" charset="-120"/>
               </a:rPr>
               <a:t>Pipeline architecture: linear, bespoke, multiplying</a:t>
             </a:r>
@@ -4651,9 +4651,9 @@
                 <a:solidFill>
                   <a:srgbClr val="EE0000"/>
                 </a:solidFill>
-                <a:latin typeface="Overpass SemiBold" pitchFamily="34" charset="0"/>
-                <a:ea typeface="Overpass SemiBold" pitchFamily="34" charset="-122"/>
-                <a:cs typeface="Overpass SemiBold" pitchFamily="34" charset="-120"/>
+                <a:latin typeface="Red Hat Display" pitchFamily="34" charset="0"/>
+                <a:ea typeface="Red Hat Display" pitchFamily="34" charset="-122"/>
+                <a:cs typeface="Red Hat Display" pitchFamily="34" charset="-120"/>
               </a:rPr>
               <a:t>DATA ARCHITECTURES</a:t>
             </a:r>
@@ -4690,9 +4690,9 @@
                 <a:solidFill>
                   <a:srgbClr val="151515"/>
                 </a:solidFill>
-                <a:latin typeface="Overpass SemiBold" pitchFamily="34" charset="0"/>
-                <a:ea typeface="Overpass SemiBold" pitchFamily="34" charset="-122"/>
-                <a:cs typeface="Overpass SemiBold" pitchFamily="34" charset="-120"/>
+                <a:latin typeface="Red Hat Display" pitchFamily="34" charset="0"/>
+                <a:ea typeface="Red Hat Display" pitchFamily="34" charset="-122"/>
+                <a:cs typeface="Red Hat Display" pitchFamily="34" charset="-120"/>
               </a:rPr>
               <a:t>Data warehouses: the single source of truth</a:t>
             </a:r>
@@ -4777,9 +4777,9 @@
                 <a:solidFill>
                   <a:srgbClr val="151515"/>
                 </a:solidFill>
-                <a:latin typeface="Overpass SemiBold" pitchFamily="34" charset="0"/>
-                <a:ea typeface="Overpass SemiBold" pitchFamily="34" charset="-122"/>
-                <a:cs typeface="Overpass SemiBold" pitchFamily="34" charset="-120"/>
+                <a:latin typeface="Red Hat Display" pitchFamily="34" charset="0"/>
+                <a:ea typeface="Red Hat Display" pitchFamily="34" charset="-122"/>
+                <a:cs typeface="Red Hat Display" pitchFamily="34" charset="-120"/>
               </a:rPr>
               <a:t>Schema-on-write</a:t>
             </a:r>
@@ -4821,9 +4821,9 @@
                 <a:solidFill>
                   <a:srgbClr val="151515"/>
                 </a:solidFill>
-                <a:latin typeface="Overpass SemiBold" pitchFamily="34" charset="0"/>
-                <a:ea typeface="Overpass SemiBold" pitchFamily="34" charset="-122"/>
-                <a:cs typeface="Overpass SemiBold" pitchFamily="34" charset="-120"/>
+                <a:latin typeface="Red Hat Display" pitchFamily="34" charset="0"/>
+                <a:ea typeface="Red Hat Display" pitchFamily="34" charset="-122"/>
+                <a:cs typeface="Red Hat Display" pitchFamily="34" charset="-120"/>
               </a:rPr>
               <a:t>The limitation: central-team bottleneck</a:t>
             </a:r>
@@ -4997,9 +4997,9 @@
                 <a:solidFill>
                   <a:srgbClr val="EE0000"/>
                 </a:solidFill>
-                <a:latin typeface="Overpass SemiBold" pitchFamily="34" charset="0"/>
-                <a:ea typeface="Overpass SemiBold" pitchFamily="34" charset="-122"/>
-                <a:cs typeface="Overpass SemiBold" pitchFamily="34" charset="-120"/>
+                <a:latin typeface="Red Hat Display" pitchFamily="34" charset="0"/>
+                <a:ea typeface="Red Hat Display" pitchFamily="34" charset="-122"/>
+                <a:cs typeface="Red Hat Display" pitchFamily="34" charset="-120"/>
               </a:rPr>
               <a:t>DATA ARCHITECTURES</a:t>
             </a:r>
@@ -5036,9 +5036,9 @@
                 <a:solidFill>
                   <a:srgbClr val="151515"/>
                 </a:solidFill>
-                <a:latin typeface="Overpass SemiBold" pitchFamily="34" charset="0"/>
-                <a:ea typeface="Overpass SemiBold" pitchFamily="34" charset="-122"/>
-                <a:cs typeface="Overpass SemiBold" pitchFamily="34" charset="-120"/>
+                <a:latin typeface="Red Hat Display" pitchFamily="34" charset="0"/>
+                <a:ea typeface="Red Hat Display" pitchFamily="34" charset="-122"/>
+                <a:cs typeface="Red Hat Display" pitchFamily="34" charset="-120"/>
               </a:rPr>
               <a:t>Warehouse architecture: many sources, one team, one store</a:t>
             </a:r>
@@ -5233,9 +5233,9 @@
                 <a:solidFill>
                   <a:srgbClr val="EE0000"/>
                 </a:solidFill>
-                <a:latin typeface="Overpass SemiBold" pitchFamily="34" charset="0"/>
-                <a:ea typeface="Overpass SemiBold" pitchFamily="34" charset="-122"/>
-                <a:cs typeface="Overpass SemiBold" pitchFamily="34" charset="-120"/>
+                <a:latin typeface="Red Hat Display" pitchFamily="34" charset="0"/>
+                <a:ea typeface="Red Hat Display" pitchFamily="34" charset="-122"/>
+                <a:cs typeface="Red Hat Display" pitchFamily="34" charset="-120"/>
               </a:rPr>
               <a:t>DATA ARCHITECTURES</a:t>
             </a:r>
@@ -5272,9 +5272,9 @@
                 <a:solidFill>
                   <a:srgbClr val="151515"/>
                 </a:solidFill>
-                <a:latin typeface="Overpass SemiBold" pitchFamily="34" charset="0"/>
-                <a:ea typeface="Overpass SemiBold" pitchFamily="34" charset="-122"/>
-                <a:cs typeface="Overpass SemiBold" pitchFamily="34" charset="-120"/>
+                <a:latin typeface="Red Hat Display" pitchFamily="34" charset="0"/>
+                <a:ea typeface="Red Hat Display" pitchFamily="34" charset="-122"/>
+                <a:cs typeface="Red Hat Display" pitchFamily="34" charset="-120"/>
               </a:rPr>
               <a:t>Data lakes: accept everything, sort it out later</a:t>
             </a:r>
@@ -5338,9 +5338,9 @@
                 <a:solidFill>
                   <a:srgbClr val="151515"/>
                 </a:solidFill>
-                <a:latin typeface="Overpass SemiBold" pitchFamily="34" charset="0"/>
-                <a:ea typeface="Overpass SemiBold" pitchFamily="34" charset="-122"/>
-                <a:cs typeface="Overpass SemiBold" pitchFamily="34" charset="-120"/>
+                <a:latin typeface="Red Hat Display" pitchFamily="34" charset="0"/>
+                <a:ea typeface="Red Hat Display" pitchFamily="34" charset="-122"/>
+                <a:cs typeface="Red Hat Display" pitchFamily="34" charset="-120"/>
               </a:rPr>
               <a:t>Zone-based organization</a:t>
             </a:r>
@@ -5382,9 +5382,9 @@
                 <a:solidFill>
                   <a:srgbClr val="151515"/>
                 </a:solidFill>
-                <a:latin typeface="Overpass SemiBold" pitchFamily="34" charset="0"/>
-                <a:ea typeface="Overpass SemiBold" pitchFamily="34" charset="-122"/>
-                <a:cs typeface="Overpass SemiBold" pitchFamily="34" charset="-120"/>
+                <a:latin typeface="Red Hat Display" pitchFamily="34" charset="0"/>
+                <a:ea typeface="Red Hat Display" pitchFamily="34" charset="-122"/>
+                <a:cs typeface="Red Hat Display" pitchFamily="34" charset="-120"/>
               </a:rPr>
               <a:t>What it solved</a:t>
             </a:r>
@@ -5426,9 +5426,9 @@
                 <a:solidFill>
                   <a:srgbClr val="151515"/>
                 </a:solidFill>
-                <a:latin typeface="Overpass SemiBold" pitchFamily="34" charset="0"/>
-                <a:ea typeface="Overpass SemiBold" pitchFamily="34" charset="-122"/>
-                <a:cs typeface="Overpass SemiBold" pitchFamily="34" charset="-120"/>
+                <a:latin typeface="Red Hat Display" pitchFamily="34" charset="0"/>
+                <a:ea typeface="Red Hat Display" pitchFamily="34" charset="-122"/>
+                <a:cs typeface="Red Hat Display" pitchFamily="34" charset="-120"/>
               </a:rPr>
               <a:t>The limitation: the swamp</a:t>
             </a:r>
@@ -5581,9 +5581,9 @@
                 <a:solidFill>
                   <a:srgbClr val="EE0000"/>
                 </a:solidFill>
-                <a:latin typeface="Overpass SemiBold" pitchFamily="34" charset="0"/>
-                <a:ea typeface="Overpass SemiBold" pitchFamily="34" charset="-122"/>
-                <a:cs typeface="Overpass SemiBold" pitchFamily="34" charset="-120"/>
+                <a:latin typeface="Red Hat Display" pitchFamily="34" charset="0"/>
+                <a:ea typeface="Red Hat Display" pitchFamily="34" charset="-122"/>
+                <a:cs typeface="Red Hat Display" pitchFamily="34" charset="-120"/>
               </a:rPr>
               <a:t>DATA ARCHITECTURES</a:t>
             </a:r>
@@ -5620,9 +5620,9 @@
                 <a:solidFill>
                   <a:srgbClr val="151515"/>
                 </a:solidFill>
-                <a:latin typeface="Overpass SemiBold" pitchFamily="34" charset="0"/>
-                <a:ea typeface="Overpass SemiBold" pitchFamily="34" charset="-122"/>
-                <a:cs typeface="Overpass SemiBold" pitchFamily="34" charset="-120"/>
+                <a:latin typeface="Red Hat Display" pitchFamily="34" charset="0"/>
+                <a:ea typeface="Red Hat Display" pitchFamily="34" charset="-122"/>
+                <a:cs typeface="Red Hat Display" pitchFamily="34" charset="-120"/>
               </a:rPr>
               <a:t>Lake architecture: zones, flexibility, and the swamp risk</a:t>
             </a:r>
@@ -5817,9 +5817,9 @@
                 <a:solidFill>
                   <a:srgbClr val="EE0000"/>
                 </a:solidFill>
-                <a:latin typeface="Overpass SemiBold" pitchFamily="34" charset="0"/>
-                <a:ea typeface="Overpass SemiBold" pitchFamily="34" charset="-122"/>
-                <a:cs typeface="Overpass SemiBold" pitchFamily="34" charset="-120"/>
+                <a:latin typeface="Red Hat Display" pitchFamily="34" charset="0"/>
+                <a:ea typeface="Red Hat Display" pitchFamily="34" charset="-122"/>
+                <a:cs typeface="Red Hat Display" pitchFamily="34" charset="-120"/>
               </a:rPr>
               <a:t>DATA ARCHITECTURES</a:t>
             </a:r>
@@ -5856,9 +5856,9 @@
                 <a:solidFill>
                   <a:srgbClr val="151515"/>
                 </a:solidFill>
-                <a:latin typeface="Overpass SemiBold" pitchFamily="34" charset="0"/>
-                <a:ea typeface="Overpass SemiBold" pitchFamily="34" charset="-122"/>
-                <a:cs typeface="Overpass SemiBold" pitchFamily="34" charset="-120"/>
+                <a:latin typeface="Red Hat Display" pitchFamily="34" charset="0"/>
+                <a:ea typeface="Red Hat Display" pitchFamily="34" charset="-122"/>
+                <a:cs typeface="Red Hat Display" pitchFamily="34" charset="-120"/>
               </a:rPr>
               <a:t>Data mesh: a different kind of answer</a:t>
             </a:r>
@@ -5922,9 +5922,9 @@
                 <a:solidFill>
                   <a:srgbClr val="151515"/>
                 </a:solidFill>
-                <a:latin typeface="Overpass SemiBold" pitchFamily="34" charset="0"/>
-                <a:ea typeface="Overpass SemiBold" pitchFamily="34" charset="-122"/>
-                <a:cs typeface="Overpass SemiBold" pitchFamily="34" charset="-120"/>
+                <a:latin typeface="Red Hat Display" pitchFamily="34" charset="0"/>
+                <a:ea typeface="Red Hat Display" pitchFamily="34" charset="-122"/>
+                <a:cs typeface="Red Hat Display" pitchFamily="34" charset="-120"/>
               </a:rPr>
               <a:t>The mesh changes the organizational shape</a:t>
             </a:r>
@@ -5987,9 +5987,9 @@
                 <a:solidFill>
                   <a:srgbClr val="151515"/>
                 </a:solidFill>
-                <a:latin typeface="Overpass SemiBold" pitchFamily="34" charset="0"/>
-                <a:ea typeface="Overpass SemiBold" pitchFamily="34" charset="-122"/>
-                <a:cs typeface="Overpass SemiBold" pitchFamily="34" charset="-120"/>
+                <a:latin typeface="Red Hat Display" pitchFamily="34" charset="0"/>
+                <a:ea typeface="Red Hat Display" pitchFamily="34" charset="-122"/>
+                <a:cs typeface="Red Hat Display" pitchFamily="34" charset="-120"/>
               </a:rPr>
               <a:t>Not a replacement</a:t>
             </a:r>

</xml_diff>

<commit_message>
docs(deck): voice + Red Hat Display pass on the data-mesh decks (#22)
* docs(deck): professional-voice pass on the data-mesh decks

Remove em dashes, chapter/section cross-references, and ban-tier verbal
tics (deliberately, earns its place, load-bearing, worth noticing, honest,
on purpose, not a toy, rest of this deck) from The Data Mesh 101 and
Data Mesh on OpenShift pptxgenjs sources, then rebuild both decks.

* docs(deck): Red Hat Display titles on the data-mesh decks

Replace the Overpass SemiBold heading font token with Red Hat Display in
both pptxgenjs sources (The Data Mesh 101, Data Mesh on OpenShift) and
rebuild; body (Red Hat Text) and code (Red Hat Mono) fonts are unchanged.
</commit_message>
<xml_diff>
--- a/presentation/data-mesh-101/The_Data_Mesh_101.pptx
+++ b/presentation/data-mesh-101/The_Data_Mesh_101.pptx
@@ -515,7 +515,7 @@
           <a:p>
             <a:r>
               <a:rPr lang="en-US" dirty="0"/>
-              <a:t>Welcome. This deck makes the case for data mesh by first grounding the audience in the landscape of data architectures that came before it. We'll walk through four patterns — data pipelines, data warehouses, data lakes, and data mesh — and show what each solves, where each stalls, and why the mesh is a different kind of answer. Then we'll define data mesh precisely through Dehghani's four principles.</a:t>
+              <a:t>Welcome. This deck makes the case for data mesh by first grounding the audience in the landscape of data architectures that came before it. We'll walk through four patterns (data pipelines, data warehouses, data lakes, and data mesh) and show what each solves, where each stalls, and why the mesh is a different kind of answer. Then we'll define data mesh precisely through Dehghani's four principles.</a:t>
             </a:r>
             <a:endParaRPr lang="en-US" dirty="0"/>
           </a:p>
@@ -603,8 +603,8 @@
           <a:p>
             <a:r>
               <a:rPr lang="en-US" dirty="0"/>
-              <a:t>Walk the diagram. Top band: federated computational governance — standards enforced by the platform, automatically. The 2x2 grid shows four domain data products — Orders, Inventory, Payment, Shipping — each a red card because this is the target pattern. Each card shows: the domain name, what it owns, 'owns its data,' three API port pills (REST, gRPC, Events), and 'team-owned' at the bottom. The bidirectional red arrows between domains show inter-domain communication — products talking to products.
-Bottom band: the self-serve data platform — shared infrastructure every domain consumes: streaming, storage, mesh, observability. This is the organizational shape that's different: no central data team owning everything. Each domain owns its own data; the platform and governance make them interoperable. The contrast with the warehouse slide should be visceral: there's no 'Central Data Team' card here.</a:t>
+              <a:t>Walk the diagram. Top band: federated computational governance, with standards enforced by the platform automatically. The 2x2 grid shows four domain data products (Orders, Inventory, Payment, Shipping), each a red card because this is the target pattern. Each card shows: the domain name, what it owns, 'owns its data,' three API port pills (REST, gRPC, Events), and 'team-owned' at the bottom. The bidirectional red arrows between domains show inter-domain communication, products talking to products.
+Bottom band: the self-serve data platform, shared infrastructure every domain consumes: streaming, storage, mesh, observability. This is the organizational shape that's different: no central data team owning everything. Each domain owns its own data; the platform and governance make them interoperable. The contrast with the warehouse slide should be visceral: there's no 'Central Data Team' card here.</a:t>
             </a:r>
             <a:endParaRPr lang="en-US" dirty="0"/>
           </a:p>
@@ -692,8 +692,8 @@
           <a:p>
             <a:r>
               <a:rPr lang="en-US" dirty="0"/>
-              <a:t>The synthesis slide. Walk left to right through the four columns. Pipelines (blue): solved the movement problem, but the limitation is pipeline sprawl and no ownership model. Warehouses (orange): solved the truth problem — a single governed view — but the limitation is the central team bottleneck. Lakes (green): solved the flexibility problem — any format, any workload — but the limitation is swamp risk and the same organizational bottleneck. Mesh (red): solves the organizational scaling problem — decentralized ownership — but requires organizational maturity.
-The bottom band makes the organizational dimension explicit: point-to-point → centralized team → centralized team (bigger) → decentralized ownership. The progression isn't 'each is better than the last' — it's 'each solves a different problem.' A pipeline is still right when movement is the problem. A warehouse is still right when truth is the problem. A lake is still right when flexibility is the problem. The mesh is right when the bottleneck is organizational.</a:t>
+              <a:t>The synthesis slide. Walk left to right through the four columns. Pipelines (blue): solved the movement problem, but the limitation is pipeline sprawl and no ownership model. Warehouses (orange): solved the truth problem (a single governed view), but the limitation is the central team bottleneck. Lakes (green): solved the flexibility problem (any format, any workload), but the limitation is swamp risk and the same organizational bottleneck. Mesh (red): solves the organizational scaling problem (decentralized ownership), but requires organizational maturity.
+The bottom band makes the organizational dimension explicit: point-to-point, then centralized team, then centralized team (bigger), then decentralized ownership. The progression isn't 'each is better than the last'; it's 'each solves a different problem.' A pipeline is still right when movement is the problem. A warehouse is still right when truth is the problem. A lake is still right when flexibility is the problem. The mesh is right when the bottleneck is organizational.</a:t>
             </a:r>
             <a:endParaRPr lang="en-US" dirty="0"/>
           </a:p>
@@ -784,9 +784,9 @@
               <a:t>This is the fitness slide. Not every organization needs a mesh. The question is whether the bottleneck is technical (better tools solve it) or organizational (who owns what). Walk each:
 • Pipelines fit when the plumbing is simple enough that sprawl hasn't started. A handful of integrations, stable flows, known sources and destinations. Don't add complexity before the problem demands it.
 • Warehouses fit when the organization needs a single source of truth for BI and reporting, and a central team has the capacity to curate the data. If the bottleneck is 'we don't know the truth,' the warehouse is the answer.
-• Lakes fit when the data is heterogeneous — logs, events, images, ML training sets — and the scale or workload patterns exceed what a warehouse handles. The bottleneck is format rigidity, not organizational ownership.
-• Mesh fits when the organization has outgrown centralized ownership. Many domains, many consumers, and the central team is the constraint. The bottleneck is organizational — not which tool to buy. The organization also needs the maturity to operate federated ownership: domain teams that can treat data as a product, a platform team that can provide self-serve infrastructure, and governance that works through automation.
-Telling people when NOT to use a mesh builds credibility for when you say they should.</a:t>
+• Lakes fit when the data is heterogeneous (logs, events, images, ML training sets) and the scale or workload patterns exceed what a warehouse handles. The bottleneck is format rigidity, not organizational ownership.
+• Mesh fits when the organization has outgrown centralized ownership. Many domains, many consumers, and the central team is the constraint. The bottleneck is organizational, not which tool to buy. The organization also needs the maturity to operate federated ownership: domain teams that can treat data as a product, a platform team that can provide self-serve infrastructure, and governance that works through automation.
+Naming when not to use a mesh makes the recommendation to use one more credible.</a:t>
             </a:r>
             <a:endParaRPr lang="en-US" dirty="0"/>
           </a:p>
@@ -874,7 +874,7 @@
           <a:p>
             <a:r>
               <a:rPr lang="en-US" dirty="0"/>
-              <a:t>Closing slide. The one-sentence definition: a mesh is the network of products plus the platform and standards that let them interoperate. And the grounding from today: each pattern we walked through solved a real problem — the mesh solves the organizational one they all left behind. Open for questions.</a:t>
+              <a:t>Closing slide. The one-sentence definition: a mesh is the network of products plus the platform and standards that let them interoperate. And the grounding from today: each pattern we walked through solved a real problem; the mesh solves the organizational one they all left behind. Open for questions.</a:t>
             </a:r>
             <a:endParaRPr lang="en-US" dirty="0"/>
           </a:p>
@@ -1050,7 +1050,7 @@
           <a:p>
             <a:r>
               <a:rPr lang="en-US" dirty="0"/>
-              <a:t>Section 1 covers the data architecture landscape. The goal is to build the audience's understanding of why data mesh exists by walking through the patterns that came before it. Each pattern solved a real problem; the mesh is not a replacement for all of them but a response to a specific organizational scaling challenge. We'll spend enough time on each to make the mesh's value proposition concrete rather than abstract.</a:t>
+              <a:t>The data architecture landscape sets up why data mesh exists. The goal is to build the audience's understanding of why data mesh exists by walking through the patterns that came before it. Each pattern solved a real problem; the mesh is not a replacement for all of them but a response to a specific organizational scaling challenge. We'll spend enough time on each to make the mesh's value proposition concrete rather than abstract.</a:t>
             </a:r>
             <a:endParaRPr lang="en-US" dirty="0"/>
           </a:p>
@@ -1138,7 +1138,7 @@
           <a:p>
             <a:r>
               <a:rPr lang="en-US" dirty="0"/>
-              <a:t>Start with the oldest pattern. Define pipelines concretely: extract-transform-load, or extract-load-transform. The distinction matters (where does the business logic live?) but both are the same shape: linear, bespoke, point-to-point. The limitation is pipeline sprawl — and it's combinatorial. 15 sources times 5 destinations isn't 20 pipelines, it's closer to 75, each with its own schedule, transformation logic, and failure modes. Nobody owns the data in a pipeline — the pipeline is plumbing, not a product. That distinction becomes central when we get to data mesh. The sprawl is what the warehouse was designed to tame.</a:t>
+              <a:t>Start with the oldest pattern. Define pipelines concretely: extract-transform-load, or extract-load-transform. The distinction matters (where does the business logic live?) but both are the same shape: linear, bespoke, point-to-point. The limitation is pipeline sprawl, and it's combinatorial. 15 sources times 5 destinations isn't 20 pipelines, it's closer to 75, each with its own schedule, transformation logic, and failure modes. Nobody owns the data in a pipeline; the pipeline is plumbing, not a product. That distinction becomes central when we get to data mesh. The sprawl is what the warehouse was designed to tame.</a:t>
             </a:r>
             <a:endParaRPr lang="en-US" dirty="0"/>
           </a:p>
@@ -1226,7 +1226,7 @@
           <a:p>
             <a:r>
               <a:rPr lang="en-US" dirty="0"/>
-              <a:t>Walk the diagram left to right. Sources on the left — CRM, ERP, logs, events — each with its own characteristics and cadence. The ETL box in the center is one pipeline, with its own transformation logic, schedule, and failure modes. Two destinations on the right. Now look at the bottom callout: pipeline sprawl. Each new source or destination doesn't just add one pipeline — it adds as many as there are things on the other side. The dashed lines show the fan-out. At organizational scale, this becomes unmanageable: nobody can see the whole picture, nobody owns the data in transit, and when something breaks at 2 a.m., the question 'whose problem is this?' rarely has a clear answer.</a:t>
+              <a:t>Walk the diagram left to right. Sources on the left (CRM, ERP, logs, events), each with its own characteristics and cadence. The ETL box in the center is one pipeline, with its own transformation logic, schedule, and failure modes. Two destinations on the right. Now look at the bottom callout: pipeline sprawl. Each new source or destination doesn't just add one pipeline; it adds as many as there are things on the other side. The dashed lines show the fan-out. At organizational scale, this becomes unmanageable: nobody can see the whole picture, nobody owns the data in transit, and when something breaks at 2 a.m., the question 'whose problem is this?' rarely has a clear answer.</a:t>
             </a:r>
             <a:endParaRPr lang="en-US" dirty="0"/>
           </a:p>
@@ -1314,8 +1314,8 @@
           <a:p>
             <a:r>
               <a:rPr lang="en-US" dirty="0"/>
-              <a:t>The warehouse solved the truth problem that pipeline sprawl created. Instead of every consumer building its own understanding from raw pipeline output, everyone queries the same curated model. Schema-on-write is the defining characteristic — and it's a feature, not a bug: when two teams query 'total revenue last quarter,' they get the same number.
-The limitation is organizational, not technical. The central data team — sometimes called the BI team, the analytics engineering team, the data platform team — becomes the bottleneck in direct proportion to the organization's growth. They own all the data but understand none of the domains. When the logistics domain needs a new dimension, the request goes to the central team, who must learn enough about logistics to model it correctly, prioritize it against every other domain's requests, and coordinate the schema change without breaking downstream consumers. The analytical view is always stale because the ingestion pipelines run on a schedule, and the central team's capacity to model new data is the real constraint.</a:t>
+              <a:t>The warehouse solved the truth problem that pipeline sprawl created. Instead of every consumer building its own understanding from raw pipeline output, everyone queries the same curated model. Schema-on-write is the defining characteristic, and it's a feature, not a bug: when two teams query 'total revenue last quarter,' they get the same number.
+The limitation is organizational, not technical. The central data team (sometimes called the BI team, the analytics engineering team, the data platform team) becomes the bottleneck in direct proportion to the organization's growth. They own all the data but understand none of the domains. When the logistics domain needs a new dimension, the request goes to the central team, who must learn enough about logistics to model it correctly, prioritize it against every other domain's requests, and coordinate the schema change without breaking downstream consumers. The analytical view is always stale because the ingestion pipelines run on a schedule, and the central team's capacity to model new data is the real constraint.</a:t>
             </a:r>
             <a:endParaRPr lang="en-US" dirty="0"/>
           </a:p>
@@ -1403,8 +1403,8 @@
           <a:p>
             <a:r>
               <a:rPr lang="en-US" dirty="0"/>
-              <a:t>Walk the hub-and-spoke. Sources on the left — the same CRM, ERP, logs, events from before — all flowing into one centralized warehouse. The warehouse card in the center lists the defining characteristics: schema-on-write, star schemas, dimensional models, governed and structured. Consumers on the right: BI dashboards, reports, analysts — all querying the same governed store.
-Now look at the bottom: the Central Data Team card. This is the bottleneck. Every schema change, every new data source, every question funnels through this one team. The dashed arrows connecting them to the warehouse make the coupling visible. They own everything but understand none of the domains. The label says it plainly: 'the bottleneck a mesh exists to remove.' This team — not the technology — is what the mesh reorganizes.</a:t>
+              <a:t>Walk the hub-and-spoke. Sources on the left (the same CRM, ERP, logs, events from before), all flowing into one centralized warehouse. The warehouse card in the center lists the defining characteristics: schema-on-write, star schemas, dimensional models, governed and structured. Consumers on the right: BI dashboards, reports, analysts, all querying the same governed store.
+Now look at the bottom: the Central Data Team card. This is the bottleneck. Every schema change, every new data source, every question funnels through this one team. The dashed arrows connecting them to the warehouse make the coupling visible. They own everything but understand none of the domains. The label calls it out: 'the bottleneck a mesh exists to remove.' This team, not the technology, is what the mesh reorganizes.</a:t>
             </a:r>
             <a:endParaRPr lang="en-US" dirty="0"/>
           </a:p>
@@ -1492,9 +1492,9 @@
           <a:p>
             <a:r>
               <a:rPr lang="en-US" dirty="0"/>
-              <a:t>The lake solved the warehouse's most visible problem: format inflexibility. The warehouse can't handle Kafka events, Parquet files, images, sensor data. The lake can. At massive scale with cheap object storage, the lake makes it feasible to keep everything and decide later what's worth querying. That flexibility unlocked workloads — ML, unstructured analytics, exploratory data science — that warehouses were never built for.
+              <a:t>The lake solved the warehouse's most visible problem: format inflexibility. The warehouse can't handle Kafka events, Parquet files, images, sensor data. The lake can. At massive scale with cheap object storage, the lake makes it feasible to keep everything and decide later what's worth querying. That flexibility unlocked workloads (ML, unstructured analytics, exploratory data science) that warehouses were never built for.
 The zone model is how well-run lakes organize the data: raw (as-is from sources), curated (cleaned, typed), refined (modeled for consumption). The progression from raw to refined represents increasing transformation and decreasing generality.
-The limitation is governance. Without active curation, the lake becomes the 'data swamp' — undocumented datasets accumulate, nobody knows which version is authoritative, which datasets are stale, which duplicate each other. The curation effort needed to make a lake useful re-creates the warehouse's modeling work, just without the warehouse's enforcement mechanisms. And the organizational problem is unchanged: a central team still owns the lake.</a:t>
+The limitation is governance. Without active curation, the lake becomes the 'data swamp': undocumented datasets accumulate, nobody knows which version is authoritative, which datasets are stale, which duplicate each other. The curation effort needed to make a lake useful re-creates the warehouse's modeling work, just without the warehouse's enforcement mechanisms. And the organizational problem is unchanged: a central team still owns the lake.</a:t>
             </a:r>
             <a:endParaRPr lang="en-US" dirty="0"/>
           </a:p>
@@ -1582,8 +1582,8 @@
           <a:p>
             <a:r>
               <a:rPr lang="en-US" dirty="0"/>
-              <a:t>Walk the architecture. Heterogeneous sources on the left — structured, semi-structured, unstructured, streaming — this is the format flexibility the lake provides. The center shows the lake with its three zones in graduated shading: the raw/landing zone (data as-is), the curated zone (cleaned and typed), the refined zone (modeled and ready for consumption). Consumers on the right: analytics, ML/AI, reporting, ad-hoc queries — the diverse workloads the lake enables.
-Now the red callout at the bottom: 'Without governance, the lake becomes a swamp.' Data lands in the raw zone and never moves. Nobody knows what's valid, what's stale, what duplicates what. Schema-on-read means consumers discover structure at query time — if they can find the data at all. And the final line: the organizational bottleneck is unchanged. A central team still owns the bucket.</a:t>
+              <a:t>Walk the architecture. Heterogeneous sources on the left (structured, semi-structured, unstructured, streaming), this is the format flexibility the lake provides. The center shows the lake with its three zones in graduated shading: the raw/landing zone (data as-is), the curated zone (cleaned and typed), the refined zone (modeled and ready for consumption). Consumers on the right: analytics, ML/AI, reporting, ad-hoc queries, the diverse workloads the lake enables.
+Now the red callout at the bottom: 'Without governance, the lake becomes a swamp.' Data lands in the raw zone and never moves. Nobody knows what's valid, what's stale, what duplicates what. Schema-on-read means consumers discover structure at query time, if they can find the data at all. And the final line: the organizational bottleneck is unchanged. A central team still owns the bucket.</a:t>
             </a:r>
             <a:endParaRPr lang="en-US" dirty="0"/>
           </a:p>
@@ -1671,9 +1671,9 @@
           <a:p>
             <a:r>
               <a:rPr lang="en-US" dirty="0"/>
-              <a:t>This is the pivot slide — from what came before to what the mesh proposes. The key insight: all three prior patterns centralize data and hand ownership to a single team. The technology improves generation by generation — from bespoke pipelines, to a governed warehouse, to a flexible lake — but the organizational shape stays the same. One team at the center, receiving requests from every domain, owning data it did not produce, modeling concepts it does not deeply understand, scaling linearly while demands grow combinatorially.
-The mesh changes the axis: instead of a better center, decentralize ownership. Each domain owns its data as a product. A shared platform provides streaming, storage, registries, observability — so domains don't each build their own. Federated governance keeps the products interoperable — through platform-enforced standards, not review boards.
-Critical clarification: the mesh is not a replacement for warehouses or lakes. A domain may use a warehouse internally. The reorganization is about who owns the data — not which database to pick. An important caveat: the mesh earns its complexity in organizations with many domains, many consumers, and the maturity to operate federated ownership. For smaller teams, a well-run warehouse may be exactly right.</a:t>
+              <a:t>This is the pivot slide, from what came before to what the mesh proposes. The key insight: all three prior patterns centralize data and hand ownership to a single team. The technology improves generation by generation, from bespoke pipelines, to a governed warehouse, to a flexible lake, but the organizational shape stays the same. One team at the center, receiving requests from every domain, owning data it did not produce, modeling concepts it does not deeply understand, scaling linearly while demands grow combinatorially.
+The mesh changes the axis: instead of a better center, decentralize ownership. Each domain owns its data as a product. A shared platform provides streaming, storage, registries, observability, so domains don't each build their own. Federated governance keeps the products interoperable, through platform-enforced standards, not review boards.
+Critical clarification: the mesh is not a replacement for warehouses or lakes. A domain may use a warehouse internally. The reorganization is about who owns the data, not which database to pick. An important caveat: the mesh's added complexity pays off in organizations with many domains, many consumers, and the maturity to operate federated ownership. For smaller teams, a well-run warehouse may be exactly right.</a:t>
             </a:r>
             <a:endParaRPr lang="en-US" dirty="0"/>
           </a:p>
@@ -2098,9 +2098,9 @@
                 <a:solidFill>
                   <a:srgbClr val="EE0000"/>
                 </a:solidFill>
-                <a:latin typeface="Overpass SemiBold" pitchFamily="34" charset="0"/>
-                <a:ea typeface="Overpass SemiBold" pitchFamily="34" charset="-122"/>
-                <a:cs typeface="Overpass SemiBold" pitchFamily="34" charset="-120"/>
+                <a:latin typeface="Red Hat Display" pitchFamily="34" charset="0"/>
+                <a:ea typeface="Red Hat Display" pitchFamily="34" charset="-122"/>
+                <a:cs typeface="Red Hat Display" pitchFamily="34" charset="-120"/>
               </a:rPr>
               <a:t>DATA MESH · PRIMER</a:t>
             </a:r>
@@ -2140,9 +2140,9 @@
                 <a:solidFill>
                   <a:srgbClr val="151515"/>
                 </a:solidFill>
-                <a:latin typeface="Overpass SemiBold" pitchFamily="34" charset="0"/>
-                <a:ea typeface="Overpass SemiBold" pitchFamily="34" charset="-122"/>
-                <a:cs typeface="Overpass SemiBold" pitchFamily="34" charset="-120"/>
+                <a:latin typeface="Red Hat Display" pitchFamily="34" charset="0"/>
+                <a:ea typeface="Red Hat Display" pitchFamily="34" charset="-122"/>
+                <a:cs typeface="Red Hat Display" pitchFamily="34" charset="-120"/>
               </a:rPr>
               <a:t>The Data Mesh</a:t>
             </a:r>
@@ -2183,7 +2183,7 @@
                 <a:ea typeface="Red Hat Text" pitchFamily="34" charset="-122"/>
                 <a:cs typeface="Red Hat Text" pitchFamily="34" charset="-120"/>
               </a:rPr>
-              <a:t>From pipelines and warehouses to decentralized, domain-owned data products — the landscape, the principles, and why the mesh is a different kind of answer.</a:t>
+              <a:t>From pipelines and warehouses to decentralized, domain-owned data products: the landscape, the principles, and why the mesh is a different kind of answer.</a:t>
             </a:r>
             <a:endParaRPr lang="en-US" sz="1700" dirty="0"/>
           </a:p>
@@ -2352,9 +2352,9 @@
                 <a:solidFill>
                   <a:srgbClr val="EE0000"/>
                 </a:solidFill>
-                <a:latin typeface="Overpass SemiBold" pitchFamily="34" charset="0"/>
-                <a:ea typeface="Overpass SemiBold" pitchFamily="34" charset="-122"/>
-                <a:cs typeface="Overpass SemiBold" pitchFamily="34" charset="-120"/>
+                <a:latin typeface="Red Hat Display" pitchFamily="34" charset="0"/>
+                <a:ea typeface="Red Hat Display" pitchFamily="34" charset="-122"/>
+                <a:cs typeface="Red Hat Display" pitchFamily="34" charset="-120"/>
               </a:rPr>
               <a:t>DATA ARCHITECTURES</a:t>
             </a:r>
@@ -2391,11 +2391,11 @@
                 <a:solidFill>
                   <a:srgbClr val="151515"/>
                 </a:solidFill>
-                <a:latin typeface="Overpass SemiBold" pitchFamily="34" charset="0"/>
-                <a:ea typeface="Overpass SemiBold" pitchFamily="34" charset="-122"/>
-                <a:cs typeface="Overpass SemiBold" pitchFamily="34" charset="-120"/>
-              </a:rPr>
-              <a:t>The mesh — decentralized, domain-owned data products</a:t>
+                <a:latin typeface="Red Hat Display" pitchFamily="34" charset="0"/>
+                <a:ea typeface="Red Hat Display" pitchFamily="34" charset="-122"/>
+                <a:cs typeface="Red Hat Display" pitchFamily="34" charset="-120"/>
+              </a:rPr>
+              <a:t>The mesh: decentralized, domain-owned data products</a:t>
             </a:r>
             <a:endParaRPr lang="en-US" sz="3000" dirty="0"/>
           </a:p>
@@ -2458,7 +2458,7 @@
                 <a:ea typeface="Red Hat Text" pitchFamily="34" charset="-122"/>
                 <a:cs typeface="Red Hat Text" pitchFamily="34" charset="-120"/>
               </a:rPr>
-              <a:t>Each domain owns its data as a product, on a shared platform under federated governance — the organizational answer.</a:t>
+              <a:t>Each domain owns its data as a product, on a shared platform under federated governance: the organizational answer.</a:t>
             </a:r>
             <a:endParaRPr lang="en-US" sz="1250" dirty="0"/>
           </a:p>
@@ -2588,9 +2588,9 @@
                 <a:solidFill>
                   <a:srgbClr val="EE0000"/>
                 </a:solidFill>
-                <a:latin typeface="Overpass SemiBold" pitchFamily="34" charset="0"/>
-                <a:ea typeface="Overpass SemiBold" pitchFamily="34" charset="-122"/>
-                <a:cs typeface="Overpass SemiBold" pitchFamily="34" charset="-120"/>
+                <a:latin typeface="Red Hat Display" pitchFamily="34" charset="0"/>
+                <a:ea typeface="Red Hat Display" pitchFamily="34" charset="-122"/>
+                <a:cs typeface="Red Hat Display" pitchFamily="34" charset="-120"/>
               </a:rPr>
               <a:t>DATA ARCHITECTURES</a:t>
             </a:r>
@@ -2627,11 +2627,11 @@
                 <a:solidFill>
                   <a:srgbClr val="151515"/>
                 </a:solidFill>
-                <a:latin typeface="Overpass SemiBold" pitchFamily="34" charset="0"/>
-                <a:ea typeface="Overpass SemiBold" pitchFamily="34" charset="-122"/>
-                <a:cs typeface="Overpass SemiBold" pitchFamily="34" charset="-120"/>
-              </a:rPr>
-              <a:t>The evolution — from pipelines to mesh</a:t>
+                <a:latin typeface="Red Hat Display" pitchFamily="34" charset="0"/>
+                <a:ea typeface="Red Hat Display" pitchFamily="34" charset="-122"/>
+                <a:cs typeface="Red Hat Display" pitchFamily="34" charset="-120"/>
+              </a:rPr>
+              <a:t>The evolution: from pipelines to mesh</a:t>
             </a:r>
             <a:endParaRPr lang="en-US" sz="3000" dirty="0"/>
           </a:p>
@@ -2824,9 +2824,9 @@
                 <a:solidFill>
                   <a:srgbClr val="EE0000"/>
                 </a:solidFill>
-                <a:latin typeface="Overpass SemiBold" pitchFamily="34" charset="0"/>
-                <a:ea typeface="Overpass SemiBold" pitchFamily="34" charset="-122"/>
-                <a:cs typeface="Overpass SemiBold" pitchFamily="34" charset="-120"/>
+                <a:latin typeface="Red Hat Display" pitchFamily="34" charset="0"/>
+                <a:ea typeface="Red Hat Display" pitchFamily="34" charset="-122"/>
+                <a:cs typeface="Red Hat Display" pitchFamily="34" charset="-120"/>
               </a:rPr>
               <a:t>DATA ARCHITECTURES</a:t>
             </a:r>
@@ -2863,9 +2863,9 @@
                 <a:solidFill>
                   <a:srgbClr val="151515"/>
                 </a:solidFill>
-                <a:latin typeface="Overpass SemiBold" pitchFamily="34" charset="0"/>
-                <a:ea typeface="Overpass SemiBold" pitchFamily="34" charset="-122"/>
-                <a:cs typeface="Overpass SemiBold" pitchFamily="34" charset="-120"/>
+                <a:latin typeface="Red Hat Display" pitchFamily="34" charset="0"/>
+                <a:ea typeface="Red Hat Display" pitchFamily="34" charset="-122"/>
+                <a:cs typeface="Red Hat Display" pitchFamily="34" charset="-120"/>
               </a:rPr>
               <a:t>When each pattern fits</a:t>
             </a:r>
@@ -2910,7 +2910,7 @@
                 <a:ea typeface="Red Hat Text" pitchFamily="34" charset="-122"/>
                 <a:cs typeface="Red Hat Text" pitchFamily="34" charset="-120"/>
               </a:rPr>
-              <a:t>The choice depends on scale, data landscape, and where the bottleneck sits — not on which pattern is newest.</a:t>
+              <a:t>The choice depends on scale, data landscape, and where the bottleneck sits, not on which pattern is newest.</a:t>
             </a:r>
             <a:endParaRPr lang="en-US" sz="1600" dirty="0"/>
           </a:p>
@@ -2929,9 +2929,9 @@
                 <a:solidFill>
                   <a:srgbClr val="151515"/>
                 </a:solidFill>
-                <a:latin typeface="Overpass SemiBold" pitchFamily="34" charset="0"/>
-                <a:ea typeface="Overpass SemiBold" pitchFamily="34" charset="-122"/>
-                <a:cs typeface="Overpass SemiBold" pitchFamily="34" charset="-120"/>
+                <a:latin typeface="Red Hat Display" pitchFamily="34" charset="0"/>
+                <a:ea typeface="Red Hat Display" pitchFamily="34" charset="-122"/>
+                <a:cs typeface="Red Hat Display" pitchFamily="34" charset="-120"/>
               </a:rPr>
               <a:t>Pipelines</a:t>
             </a:r>
@@ -2973,9 +2973,9 @@
                 <a:solidFill>
                   <a:srgbClr val="151515"/>
                 </a:solidFill>
-                <a:latin typeface="Overpass SemiBold" pitchFamily="34" charset="0"/>
-                <a:ea typeface="Overpass SemiBold" pitchFamily="34" charset="-122"/>
-                <a:cs typeface="Overpass SemiBold" pitchFamily="34" charset="-120"/>
+                <a:latin typeface="Red Hat Display" pitchFamily="34" charset="0"/>
+                <a:ea typeface="Red Hat Display" pitchFamily="34" charset="-122"/>
+                <a:cs typeface="Red Hat Display" pitchFamily="34" charset="-120"/>
               </a:rPr>
               <a:t>Warehouse</a:t>
             </a:r>
@@ -2998,7 +2998,7 @@
                 <a:ea typeface="Red Hat Text" pitchFamily="34" charset="-122"/>
                 <a:cs typeface="Red Hat Text" pitchFamily="34" charset="-120"/>
               </a:rPr>
-              <a:t>The organization needs a governed analytical view — BI, reporting, structured decisions — and a central team has the capacity to curate it. The bottleneck is the absence of a single source of truth.</a:t>
+              <a:t>The organization needs a governed analytical view (BI, reporting, structured decisions) and a central team has the capacity to curate it. The bottleneck is the absence of a single source of truth.</a:t>
             </a:r>
             <a:endParaRPr lang="en-US" sz="1600" dirty="0"/>
           </a:p>
@@ -3017,9 +3017,9 @@
                 <a:solidFill>
                   <a:srgbClr val="151515"/>
                 </a:solidFill>
-                <a:latin typeface="Overpass SemiBold" pitchFamily="34" charset="0"/>
-                <a:ea typeface="Overpass SemiBold" pitchFamily="34" charset="-122"/>
-                <a:cs typeface="Overpass SemiBold" pitchFamily="34" charset="-120"/>
+                <a:latin typeface="Red Hat Display" pitchFamily="34" charset="0"/>
+                <a:ea typeface="Red Hat Display" pitchFamily="34" charset="-122"/>
+                <a:cs typeface="Red Hat Display" pitchFamily="34" charset="-120"/>
               </a:rPr>
               <a:t>Lake</a:t>
             </a:r>
@@ -3061,9 +3061,9 @@
                 <a:solidFill>
                   <a:srgbClr val="151515"/>
                 </a:solidFill>
-                <a:latin typeface="Overpass SemiBold" pitchFamily="34" charset="0"/>
-                <a:ea typeface="Overpass SemiBold" pitchFamily="34" charset="-122"/>
-                <a:cs typeface="Overpass SemiBold" pitchFamily="34" charset="-120"/>
+                <a:latin typeface="Red Hat Display" pitchFamily="34" charset="0"/>
+                <a:ea typeface="Red Hat Display" pitchFamily="34" charset="-122"/>
+                <a:cs typeface="Red Hat Display" pitchFamily="34" charset="-120"/>
               </a:rPr>
               <a:t>Mesh</a:t>
             </a:r>
@@ -3086,7 +3086,7 @@
                 <a:ea typeface="Red Hat Text" pitchFamily="34" charset="-122"/>
                 <a:cs typeface="Red Hat Text" pitchFamily="34" charset="-120"/>
               </a:rPr>
-              <a:t>Many domains, many consumers, and the central team has become the constraint. The bottleneck is organizational — who owns what — not technical.</a:t>
+              <a:t>Many domains, many consumers, and the central team has become the constraint. The bottleneck is organizational (who owns what), not technical.</a:t>
             </a:r>
             <a:endParaRPr lang="en-US" sz="1600" dirty="0"/>
           </a:p>
@@ -3232,11 +3232,11 @@
                 <a:solidFill>
                   <a:srgbClr val="FFFFFF"/>
                 </a:solidFill>
-                <a:latin typeface="Overpass SemiBold" pitchFamily="34" charset="0"/>
-                <a:ea typeface="Overpass SemiBold" pitchFamily="34" charset="-122"/>
-                <a:cs typeface="Overpass SemiBold" pitchFamily="34" charset="-120"/>
-              </a:rPr>
-              <a:t>The mesh is the network of products —</a:t>
+                <a:latin typeface="Red Hat Display" pitchFamily="34" charset="0"/>
+                <a:ea typeface="Red Hat Display" pitchFamily="34" charset="-122"/>
+                <a:cs typeface="Red Hat Display" pitchFamily="34" charset="-120"/>
+              </a:rPr>
+              <a:t>The mesh is the network of products,</a:t>
             </a:r>
             <a:endParaRPr lang="en-US" sz="2800" dirty="0"/>
           </a:p>
@@ -3271,9 +3271,9 @@
                 <a:solidFill>
                   <a:srgbClr val="FFD9D9"/>
                 </a:solidFill>
-                <a:latin typeface="Overpass SemiBold" pitchFamily="34" charset="0"/>
-                <a:ea typeface="Overpass SemiBold" pitchFamily="34" charset="-122"/>
-                <a:cs typeface="Overpass SemiBold" pitchFamily="34" charset="-120"/>
+                <a:latin typeface="Red Hat Display" pitchFamily="34" charset="0"/>
+                <a:ea typeface="Red Hat Display" pitchFamily="34" charset="-122"/>
+                <a:cs typeface="Red Hat Display" pitchFamily="34" charset="-120"/>
               </a:rPr>
               <a:t>plus the platform and standards</a:t>
             </a:r>
@@ -3288,9 +3288,9 @@
                 <a:solidFill>
                   <a:srgbClr val="FFD9D9"/>
                 </a:solidFill>
-                <a:latin typeface="Overpass SemiBold" pitchFamily="34" charset="0"/>
-                <a:ea typeface="Overpass SemiBold" pitchFamily="34" charset="-122"/>
-                <a:cs typeface="Overpass SemiBold" pitchFamily="34" charset="-120"/>
+                <a:latin typeface="Red Hat Display" pitchFamily="34" charset="0"/>
+                <a:ea typeface="Red Hat Display" pitchFamily="34" charset="-122"/>
+                <a:cs typeface="Red Hat Display" pitchFamily="34" charset="-120"/>
               </a:rPr>
               <a:t>that let them interoperate.</a:t>
             </a:r>
@@ -3485,9 +3485,9 @@
                 <a:solidFill>
                   <a:srgbClr val="EE0000"/>
                 </a:solidFill>
-                <a:latin typeface="Overpass SemiBold" pitchFamily="34" charset="0"/>
-                <a:ea typeface="Overpass SemiBold" pitchFamily="34" charset="-122"/>
-                <a:cs typeface="Overpass SemiBold" pitchFamily="34" charset="-120"/>
+                <a:latin typeface="Red Hat Display" pitchFamily="34" charset="0"/>
+                <a:ea typeface="Red Hat Display" pitchFamily="34" charset="-122"/>
+                <a:cs typeface="Red Hat Display" pitchFamily="34" charset="-120"/>
               </a:rPr>
               <a:t>SCAN TO EXPLORE</a:t>
             </a:r>
@@ -3524,9 +3524,9 @@
                 <a:solidFill>
                   <a:srgbClr val="151515"/>
                 </a:solidFill>
-                <a:latin typeface="Overpass SemiBold" pitchFamily="34" charset="0"/>
-                <a:ea typeface="Overpass SemiBold" pitchFamily="34" charset="-122"/>
-                <a:cs typeface="Overpass SemiBold" pitchFamily="34" charset="-120"/>
+                <a:latin typeface="Red Hat Display" pitchFamily="34" charset="0"/>
+                <a:ea typeface="Red Hat Display" pitchFamily="34" charset="-122"/>
+                <a:cs typeface="Red Hat Display" pitchFamily="34" charset="-120"/>
               </a:rPr>
               <a:t>Take it with you</a:t>
             </a:r>
@@ -3587,9 +3587,9 @@
                 <a:solidFill>
                   <a:srgbClr val="151515"/>
                 </a:solidFill>
-                <a:latin typeface="Overpass SemiBold" pitchFamily="34" charset="0"/>
-                <a:ea typeface="Overpass SemiBold" pitchFamily="34" charset="-122"/>
-                <a:cs typeface="Overpass SemiBold" pitchFamily="34" charset="-120"/>
+                <a:latin typeface="Red Hat Display" pitchFamily="34" charset="0"/>
+                <a:ea typeface="Red Hat Display" pitchFamily="34" charset="-122"/>
+                <a:cs typeface="Red Hat Display" pitchFamily="34" charset="-120"/>
               </a:rPr>
               <a:t>The reference architecture</a:t>
             </a:r>
@@ -3728,9 +3728,9 @@
                 <a:solidFill>
                   <a:srgbClr val="151515"/>
                 </a:solidFill>
-                <a:latin typeface="Overpass SemiBold" pitchFamily="34" charset="0"/>
-                <a:ea typeface="Overpass SemiBold" pitchFamily="34" charset="-122"/>
-                <a:cs typeface="Overpass SemiBold" pitchFamily="34" charset="-120"/>
+                <a:latin typeface="Red Hat Display" pitchFamily="34" charset="0"/>
+                <a:ea typeface="Red Hat Display" pitchFamily="34" charset="-122"/>
+                <a:cs typeface="Red Hat Display" pitchFamily="34" charset="-120"/>
               </a:rPr>
               <a:t>Workshops &amp; Tutorials</a:t>
             </a:r>
@@ -3935,9 +3935,9 @@
                 <a:solidFill>
                   <a:srgbClr val="FFFFFF"/>
                 </a:solidFill>
-                <a:latin typeface="Overpass SemiBold" pitchFamily="34" charset="0"/>
-                <a:ea typeface="Overpass SemiBold" pitchFamily="34" charset="-122"/>
-                <a:cs typeface="Overpass SemiBold" pitchFamily="34" charset="-120"/>
+                <a:latin typeface="Red Hat Display" pitchFamily="34" charset="0"/>
+                <a:ea typeface="Red Hat Display" pitchFamily="34" charset="-122"/>
+                <a:cs typeface="Red Hat Display" pitchFamily="34" charset="-120"/>
               </a:rPr>
               <a:t>The landscape</a:t>
             </a:r>
@@ -3978,7 +3978,7 @@
                 <a:ea typeface="Red Hat Text" pitchFamily="34" charset="-122"/>
                 <a:cs typeface="Red Hat Text" pitchFamily="34" charset="-120"/>
               </a:rPr>
-              <a:t>Four data architectures — what each pattern solves and the limitation it leaves behind.</a:t>
+              <a:t>Four data architectures: what each pattern solves and the limitation it leaves behind.</a:t>
             </a:r>
             <a:endParaRPr lang="en-US" sz="1600" dirty="0"/>
           </a:p>
@@ -4069,9 +4069,9 @@
                 <a:solidFill>
                   <a:srgbClr val="EE0000"/>
                 </a:solidFill>
-                <a:latin typeface="Overpass SemiBold" pitchFamily="34" charset="0"/>
-                <a:ea typeface="Overpass SemiBold" pitchFamily="34" charset="-122"/>
-                <a:cs typeface="Overpass SemiBold" pitchFamily="34" charset="-120"/>
+                <a:latin typeface="Red Hat Display" pitchFamily="34" charset="0"/>
+                <a:ea typeface="Red Hat Display" pitchFamily="34" charset="-122"/>
+                <a:cs typeface="Red Hat Display" pitchFamily="34" charset="-120"/>
               </a:rPr>
               <a:t>DATA ARCHITECTURES</a:t>
             </a:r>
@@ -4108,11 +4108,11 @@
                 <a:solidFill>
                   <a:srgbClr val="151515"/>
                 </a:solidFill>
-                <a:latin typeface="Overpass SemiBold" pitchFamily="34" charset="0"/>
-                <a:ea typeface="Overpass SemiBold" pitchFamily="34" charset="-122"/>
-                <a:cs typeface="Overpass SemiBold" pitchFamily="34" charset="-120"/>
-              </a:rPr>
-              <a:t>Data pipelines — the plumbing</a:t>
+                <a:latin typeface="Red Hat Display" pitchFamily="34" charset="0"/>
+                <a:ea typeface="Red Hat Display" pitchFamily="34" charset="-122"/>
+                <a:cs typeface="Red Hat Display" pitchFamily="34" charset="-120"/>
+              </a:rPr>
+              <a:t>Data pipelines: the plumbing</a:t>
             </a:r>
             <a:endParaRPr lang="en-US" sz="3000" dirty="0"/>
           </a:p>
@@ -4176,7 +4176,7 @@
                 <a:ea typeface="Red Hat Text" pitchFamily="34" charset="-122"/>
                 <a:cs typeface="Red Hat Text" pitchFamily="34" charset="-120"/>
               </a:rPr>
-              <a:t>A data pipeline is that something — a sequence of steps that extracts data from a source, transforms it, and loads it into a target store.</a:t>
+              <a:t>A data pipeline is that something: a sequence of steps that extracts data from a source, transforms it, and loads it into a target store.</a:t>
             </a:r>
             <a:endParaRPr lang="en-US" sz="1600" dirty="0"/>
           </a:p>
@@ -4195,9 +4195,9 @@
                 <a:solidFill>
                   <a:srgbClr val="151515"/>
                 </a:solidFill>
-                <a:latin typeface="Overpass SemiBold" pitchFamily="34" charset="0"/>
-                <a:ea typeface="Overpass SemiBold" pitchFamily="34" charset="-122"/>
-                <a:cs typeface="Overpass SemiBold" pitchFamily="34" charset="-120"/>
+                <a:latin typeface="Red Hat Display" pitchFamily="34" charset="0"/>
+                <a:ea typeface="Red Hat Display" pitchFamily="34" charset="-122"/>
+                <a:cs typeface="Red Hat Display" pitchFamily="34" charset="-120"/>
               </a:rPr>
               <a:t>ETL vs. ELT</a:t>
             </a:r>
@@ -4260,9 +4260,9 @@
                 <a:solidFill>
                   <a:srgbClr val="151515"/>
                 </a:solidFill>
-                <a:latin typeface="Overpass SemiBold" pitchFamily="34" charset="0"/>
-                <a:ea typeface="Overpass SemiBold" pitchFamily="34" charset="-122"/>
-                <a:cs typeface="Overpass SemiBold" pitchFamily="34" charset="-120"/>
+                <a:latin typeface="Red Hat Display" pitchFamily="34" charset="0"/>
+                <a:ea typeface="Red Hat Display" pitchFamily="34" charset="-122"/>
+                <a:cs typeface="Red Hat Display" pitchFamily="34" charset="-120"/>
               </a:rPr>
               <a:t>The limitation: pipeline sprawl</a:t>
             </a:r>
@@ -4285,7 +4285,7 @@
                 <a:ea typeface="Red Hat Text" pitchFamily="34" charset="-122"/>
                 <a:cs typeface="Red Hat Text" pitchFamily="34" charset="-120"/>
               </a:rPr>
-              <a:t>Each source-destination pair needs its own pipeline. The total grows as the product of sources and destinations, not the sum. Nobody 'owns' the data flowing through a pipeline — the pipeline is plumbing, not a product.</a:t>
+              <a:t>Each source-destination pair needs its own pipeline. The total grows as the product of sources and destinations, not the sum. Nobody 'owns' the data flowing through a pipeline; the pipeline is plumbing, not a product.</a:t>
             </a:r>
             <a:endParaRPr lang="en-US" sz="1600" dirty="0"/>
           </a:p>
@@ -4415,9 +4415,9 @@
                 <a:solidFill>
                   <a:srgbClr val="EE0000"/>
                 </a:solidFill>
-                <a:latin typeface="Overpass SemiBold" pitchFamily="34" charset="0"/>
-                <a:ea typeface="Overpass SemiBold" pitchFamily="34" charset="-122"/>
-                <a:cs typeface="Overpass SemiBold" pitchFamily="34" charset="-120"/>
+                <a:latin typeface="Red Hat Display" pitchFamily="34" charset="0"/>
+                <a:ea typeface="Red Hat Display" pitchFamily="34" charset="-122"/>
+                <a:cs typeface="Red Hat Display" pitchFamily="34" charset="-120"/>
               </a:rPr>
               <a:t>DATA ARCHITECTURES</a:t>
             </a:r>
@@ -4454,11 +4454,11 @@
                 <a:solidFill>
                   <a:srgbClr val="151515"/>
                 </a:solidFill>
-                <a:latin typeface="Overpass SemiBold" pitchFamily="34" charset="0"/>
-                <a:ea typeface="Overpass SemiBold" pitchFamily="34" charset="-122"/>
-                <a:cs typeface="Overpass SemiBold" pitchFamily="34" charset="-120"/>
-              </a:rPr>
-              <a:t>Pipeline architecture — linear, bespoke, multiplying</a:t>
+                <a:latin typeface="Red Hat Display" pitchFamily="34" charset="0"/>
+                <a:ea typeface="Red Hat Display" pitchFamily="34" charset="-122"/>
+                <a:cs typeface="Red Hat Display" pitchFamily="34" charset="-120"/>
+              </a:rPr>
+              <a:t>Pipeline architecture: linear, bespoke, multiplying</a:t>
             </a:r>
             <a:endParaRPr lang="en-US" sz="3000" dirty="0"/>
           </a:p>
@@ -4651,9 +4651,9 @@
                 <a:solidFill>
                   <a:srgbClr val="EE0000"/>
                 </a:solidFill>
-                <a:latin typeface="Overpass SemiBold" pitchFamily="34" charset="0"/>
-                <a:ea typeface="Overpass SemiBold" pitchFamily="34" charset="-122"/>
-                <a:cs typeface="Overpass SemiBold" pitchFamily="34" charset="-120"/>
+                <a:latin typeface="Red Hat Display" pitchFamily="34" charset="0"/>
+                <a:ea typeface="Red Hat Display" pitchFamily="34" charset="-122"/>
+                <a:cs typeface="Red Hat Display" pitchFamily="34" charset="-120"/>
               </a:rPr>
               <a:t>DATA ARCHITECTURES</a:t>
             </a:r>
@@ -4690,11 +4690,11 @@
                 <a:solidFill>
                   <a:srgbClr val="151515"/>
                 </a:solidFill>
-                <a:latin typeface="Overpass SemiBold" pitchFamily="34" charset="0"/>
-                <a:ea typeface="Overpass SemiBold" pitchFamily="34" charset="-122"/>
-                <a:cs typeface="Overpass SemiBold" pitchFamily="34" charset="-120"/>
-              </a:rPr>
-              <a:t>Data warehouses — the single source of truth</a:t>
+                <a:latin typeface="Red Hat Display" pitchFamily="34" charset="0"/>
+                <a:ea typeface="Red Hat Display" pitchFamily="34" charset="-122"/>
+                <a:cs typeface="Red Hat Display" pitchFamily="34" charset="-120"/>
+              </a:rPr>
+              <a:t>Data warehouses: the single source of truth</a:t>
             </a:r>
             <a:endParaRPr lang="en-US" sz="3000" dirty="0"/>
           </a:p>
@@ -4758,7 +4758,7 @@
                 <a:ea typeface="Red Hat Text" pitchFamily="34" charset="-122"/>
                 <a:cs typeface="Red Hat Text" pitchFamily="34" charset="-120"/>
               </a:rPr>
-              <a:t>Star schemas, fact tables, dimension tables — all optimized for the aggregations and joins that BI tools need.</a:t>
+              <a:t>Star schemas, fact tables, dimension tables: all optimized for the aggregations and joins that BI tools need.</a:t>
             </a:r>
             <a:endParaRPr lang="en-US" sz="1600" dirty="0"/>
           </a:p>
@@ -4777,9 +4777,9 @@
                 <a:solidFill>
                   <a:srgbClr val="151515"/>
                 </a:solidFill>
-                <a:latin typeface="Overpass SemiBold" pitchFamily="34" charset="0"/>
-                <a:ea typeface="Overpass SemiBold" pitchFamily="34" charset="-122"/>
-                <a:cs typeface="Overpass SemiBold" pitchFamily="34" charset="-120"/>
+                <a:latin typeface="Red Hat Display" pitchFamily="34" charset="0"/>
+                <a:ea typeface="Red Hat Display" pitchFamily="34" charset="-122"/>
+                <a:cs typeface="Red Hat Display" pitchFamily="34" charset="-120"/>
               </a:rPr>
               <a:t>Schema-on-write</a:t>
             </a:r>
@@ -4821,9 +4821,9 @@
                 <a:solidFill>
                   <a:srgbClr val="151515"/>
                 </a:solidFill>
-                <a:latin typeface="Overpass SemiBold" pitchFamily="34" charset="0"/>
-                <a:ea typeface="Overpass SemiBold" pitchFamily="34" charset="-122"/>
-                <a:cs typeface="Overpass SemiBold" pitchFamily="34" charset="-120"/>
+                <a:latin typeface="Red Hat Display" pitchFamily="34" charset="0"/>
+                <a:ea typeface="Red Hat Display" pitchFamily="34" charset="-122"/>
+                <a:cs typeface="Red Hat Display" pitchFamily="34" charset="-120"/>
               </a:rPr>
               <a:t>The limitation: central-team bottleneck</a:t>
             </a:r>
@@ -4867,7 +4867,7 @@
                 <a:ea typeface="Red Hat Text" pitchFamily="34" charset="-122"/>
                 <a:cs typeface="Red Hat Text" pitchFamily="34" charset="-120"/>
               </a:rPr>
-              <a:t>As the organization grows, the central team processes more requests than it can understand — the queue becomes the bottleneck.</a:t>
+              <a:t>As the organization grows, the central team processes more requests than it can understand; the queue becomes the bottleneck.</a:t>
             </a:r>
             <a:endParaRPr lang="en-US" sz="1600" dirty="0"/>
           </a:p>
@@ -4997,9 +4997,9 @@
                 <a:solidFill>
                   <a:srgbClr val="EE0000"/>
                 </a:solidFill>
-                <a:latin typeface="Overpass SemiBold" pitchFamily="34" charset="0"/>
-                <a:ea typeface="Overpass SemiBold" pitchFamily="34" charset="-122"/>
-                <a:cs typeface="Overpass SemiBold" pitchFamily="34" charset="-120"/>
+                <a:latin typeface="Red Hat Display" pitchFamily="34" charset="0"/>
+                <a:ea typeface="Red Hat Display" pitchFamily="34" charset="-122"/>
+                <a:cs typeface="Red Hat Display" pitchFamily="34" charset="-120"/>
               </a:rPr>
               <a:t>DATA ARCHITECTURES</a:t>
             </a:r>
@@ -5036,11 +5036,11 @@
                 <a:solidFill>
                   <a:srgbClr val="151515"/>
                 </a:solidFill>
-                <a:latin typeface="Overpass SemiBold" pitchFamily="34" charset="0"/>
-                <a:ea typeface="Overpass SemiBold" pitchFamily="34" charset="-122"/>
-                <a:cs typeface="Overpass SemiBold" pitchFamily="34" charset="-120"/>
-              </a:rPr>
-              <a:t>Warehouse architecture — many sources, one team, one store</a:t>
+                <a:latin typeface="Red Hat Display" pitchFamily="34" charset="0"/>
+                <a:ea typeface="Red Hat Display" pitchFamily="34" charset="-122"/>
+                <a:cs typeface="Red Hat Display" pitchFamily="34" charset="-120"/>
+              </a:rPr>
+              <a:t>Warehouse architecture: many sources, one team, one store</a:t>
             </a:r>
             <a:endParaRPr lang="en-US" sz="3000" dirty="0"/>
           </a:p>
@@ -5103,7 +5103,7 @@
                 <a:ea typeface="Red Hat Text" pitchFamily="34" charset="-122"/>
                 <a:cs typeface="Red Hat Text" pitchFamily="34" charset="-120"/>
               </a:rPr>
-              <a:t>Many sources, one warehouse, one team — the single source of truth, and the single point of contention.</a:t>
+              <a:t>Many sources, one warehouse, one team: the single source of truth, and the single point of contention.</a:t>
             </a:r>
             <a:endParaRPr lang="en-US" sz="1250" dirty="0"/>
           </a:p>
@@ -5233,9 +5233,9 @@
                 <a:solidFill>
                   <a:srgbClr val="EE0000"/>
                 </a:solidFill>
-                <a:latin typeface="Overpass SemiBold" pitchFamily="34" charset="0"/>
-                <a:ea typeface="Overpass SemiBold" pitchFamily="34" charset="-122"/>
-                <a:cs typeface="Overpass SemiBold" pitchFamily="34" charset="-120"/>
+                <a:latin typeface="Red Hat Display" pitchFamily="34" charset="0"/>
+                <a:ea typeface="Red Hat Display" pitchFamily="34" charset="-122"/>
+                <a:cs typeface="Red Hat Display" pitchFamily="34" charset="-120"/>
               </a:rPr>
               <a:t>DATA ARCHITECTURES</a:t>
             </a:r>
@@ -5272,11 +5272,11 @@
                 <a:solidFill>
                   <a:srgbClr val="151515"/>
                 </a:solidFill>
-                <a:latin typeface="Overpass SemiBold" pitchFamily="34" charset="0"/>
-                <a:ea typeface="Overpass SemiBold" pitchFamily="34" charset="-122"/>
-                <a:cs typeface="Overpass SemiBold" pitchFamily="34" charset="-120"/>
-              </a:rPr>
-              <a:t>Data lakes — accept everything, sort it out later</a:t>
+                <a:latin typeface="Red Hat Display" pitchFamily="34" charset="0"/>
+                <a:ea typeface="Red Hat Display" pitchFamily="34" charset="-122"/>
+                <a:cs typeface="Red Hat Display" pitchFamily="34" charset="-120"/>
+              </a:rPr>
+              <a:t>Data lakes: accept everything, sort it out later</a:t>
             </a:r>
             <a:endParaRPr lang="en-US" sz="3000" dirty="0"/>
           </a:p>
@@ -5319,7 +5319,7 @@
                 <a:ea typeface="Red Hat Text" pitchFamily="34" charset="-122"/>
                 <a:cs typeface="Red Hat Text" pitchFamily="34" charset="-120"/>
               </a:rPr>
-              <a:t>A data lake accepts data in any format — structured, semi-structured, unstructured, streaming — and defers schema decisions to the point of consumption. This is schema-on-read.</a:t>
+              <a:t>A data lake accepts data in any format (structured, semi-structured, unstructured, streaming) and defers schema decisions to the point of consumption. This is schema-on-read.</a:t>
             </a:r>
             <a:endParaRPr lang="en-US" sz="1600" dirty="0"/>
           </a:p>
@@ -5338,9 +5338,9 @@
                 <a:solidFill>
                   <a:srgbClr val="151515"/>
                 </a:solidFill>
-                <a:latin typeface="Overpass SemiBold" pitchFamily="34" charset="0"/>
-                <a:ea typeface="Overpass SemiBold" pitchFamily="34" charset="-122"/>
-                <a:cs typeface="Overpass SemiBold" pitchFamily="34" charset="-120"/>
+                <a:latin typeface="Red Hat Display" pitchFamily="34" charset="0"/>
+                <a:ea typeface="Red Hat Display" pitchFamily="34" charset="-122"/>
+                <a:cs typeface="Red Hat Display" pitchFamily="34" charset="-120"/>
               </a:rPr>
               <a:t>Zone-based organization</a:t>
             </a:r>
@@ -5382,9 +5382,9 @@
                 <a:solidFill>
                   <a:srgbClr val="151515"/>
                 </a:solidFill>
-                <a:latin typeface="Overpass SemiBold" pitchFamily="34" charset="0"/>
-                <a:ea typeface="Overpass SemiBold" pitchFamily="34" charset="-122"/>
-                <a:cs typeface="Overpass SemiBold" pitchFamily="34" charset="-120"/>
+                <a:latin typeface="Red Hat Display" pitchFamily="34" charset="0"/>
+                <a:ea typeface="Red Hat Display" pitchFamily="34" charset="-122"/>
+                <a:cs typeface="Red Hat Display" pitchFamily="34" charset="-120"/>
               </a:rPr>
               <a:t>What it solved</a:t>
             </a:r>
@@ -5426,9 +5426,9 @@
                 <a:solidFill>
                   <a:srgbClr val="151515"/>
                 </a:solidFill>
-                <a:latin typeface="Overpass SemiBold" pitchFamily="34" charset="0"/>
-                <a:ea typeface="Overpass SemiBold" pitchFamily="34" charset="-122"/>
-                <a:cs typeface="Overpass SemiBold" pitchFamily="34" charset="-120"/>
+                <a:latin typeface="Red Hat Display" pitchFamily="34" charset="0"/>
+                <a:ea typeface="Red Hat Display" pitchFamily="34" charset="-122"/>
+                <a:cs typeface="Red Hat Display" pitchFamily="34" charset="-120"/>
               </a:rPr>
               <a:t>The limitation: the swamp</a:t>
             </a:r>
@@ -5451,7 +5451,7 @@
                 <a:ea typeface="Red Hat Text" pitchFamily="34" charset="-122"/>
                 <a:cs typeface="Red Hat Text" pitchFamily="34" charset="-120"/>
               </a:rPr>
-              <a:t>Without governance, the lake becomes a data swamp — undocumented, stale, duplicated datasets nobody trusts. The curation effort re-creates warehouse work, and a central team still owns the bucket.</a:t>
+              <a:t>Without governance, the lake becomes a data swamp: undocumented, stale, duplicated datasets nobody trusts. The curation effort re-creates warehouse work, and a central team still owns the bucket.</a:t>
             </a:r>
             <a:endParaRPr lang="en-US" sz="1600" dirty="0"/>
           </a:p>
@@ -5581,9 +5581,9 @@
                 <a:solidFill>
                   <a:srgbClr val="EE0000"/>
                 </a:solidFill>
-                <a:latin typeface="Overpass SemiBold" pitchFamily="34" charset="0"/>
-                <a:ea typeface="Overpass SemiBold" pitchFamily="34" charset="-122"/>
-                <a:cs typeface="Overpass SemiBold" pitchFamily="34" charset="-120"/>
+                <a:latin typeface="Red Hat Display" pitchFamily="34" charset="0"/>
+                <a:ea typeface="Red Hat Display" pitchFamily="34" charset="-122"/>
+                <a:cs typeface="Red Hat Display" pitchFamily="34" charset="-120"/>
               </a:rPr>
               <a:t>DATA ARCHITECTURES</a:t>
             </a:r>
@@ -5620,11 +5620,11 @@
                 <a:solidFill>
                   <a:srgbClr val="151515"/>
                 </a:solidFill>
-                <a:latin typeface="Overpass SemiBold" pitchFamily="34" charset="0"/>
-                <a:ea typeface="Overpass SemiBold" pitchFamily="34" charset="-122"/>
-                <a:cs typeface="Overpass SemiBold" pitchFamily="34" charset="-120"/>
-              </a:rPr>
-              <a:t>Lake architecture — zones, flexibility, and the swamp risk</a:t>
+                <a:latin typeface="Red Hat Display" pitchFamily="34" charset="0"/>
+                <a:ea typeface="Red Hat Display" pitchFamily="34" charset="-122"/>
+                <a:cs typeface="Red Hat Display" pitchFamily="34" charset="-120"/>
+              </a:rPr>
+              <a:t>Lake architecture: zones, flexibility, and the swamp risk</a:t>
             </a:r>
             <a:endParaRPr lang="en-US" sz="3000" dirty="0"/>
           </a:p>
@@ -5687,7 +5687,7 @@
                 <a:ea typeface="Red Hat Text" pitchFamily="34" charset="-122"/>
                 <a:cs typeface="Red Hat Text" pitchFamily="34" charset="-120"/>
               </a:rPr>
-              <a:t>Raw, curated, refined — flexible on the way in, but without governance the lake becomes a swamp, and the central-team bottleneck remains.</a:t>
+              <a:t>Raw, curated, refined: flexible on the way in, but without governance the lake becomes a swamp, and the central-team bottleneck remains.</a:t>
             </a:r>
             <a:endParaRPr lang="en-US" sz="1250" dirty="0"/>
           </a:p>
@@ -5817,9 +5817,9 @@
                 <a:solidFill>
                   <a:srgbClr val="EE0000"/>
                 </a:solidFill>
-                <a:latin typeface="Overpass SemiBold" pitchFamily="34" charset="0"/>
-                <a:ea typeface="Overpass SemiBold" pitchFamily="34" charset="-122"/>
-                <a:cs typeface="Overpass SemiBold" pitchFamily="34" charset="-120"/>
+                <a:latin typeface="Red Hat Display" pitchFamily="34" charset="0"/>
+                <a:ea typeface="Red Hat Display" pitchFamily="34" charset="-122"/>
+                <a:cs typeface="Red Hat Display" pitchFamily="34" charset="-120"/>
               </a:rPr>
               <a:t>DATA ARCHITECTURES</a:t>
             </a:r>
@@ -5856,11 +5856,11 @@
                 <a:solidFill>
                   <a:srgbClr val="151515"/>
                 </a:solidFill>
-                <a:latin typeface="Overpass SemiBold" pitchFamily="34" charset="0"/>
-                <a:ea typeface="Overpass SemiBold" pitchFamily="34" charset="-122"/>
-                <a:cs typeface="Overpass SemiBold" pitchFamily="34" charset="-120"/>
-              </a:rPr>
-              <a:t>Data mesh — a different kind of answer</a:t>
+                <a:latin typeface="Red Hat Display" pitchFamily="34" charset="0"/>
+                <a:ea typeface="Red Hat Display" pitchFamily="34" charset="-122"/>
+                <a:cs typeface="Red Hat Display" pitchFamily="34" charset="-120"/>
+              </a:rPr>
+              <a:t>Data mesh: a different kind of answer</a:t>
             </a:r>
             <a:endParaRPr lang="en-US" sz="3000" dirty="0"/>
           </a:p>
@@ -5903,7 +5903,7 @@
                 <a:ea typeface="Red Hat Text" pitchFamily="34" charset="-122"/>
                 <a:cs typeface="Red Hat Text" pitchFamily="34" charset="-120"/>
               </a:rPr>
-              <a:t>All three patterns — pipelines, warehouses, lakes — centralize data and hand ownership to a single team. The technology improves; the organizational shape stays the same: one team at the center.</a:t>
+              <a:t>All three patterns (pipelines, warehouses, lakes) centralize data and hand ownership to a single team. The technology improves; the organizational shape stays the same: one team at the center.</a:t>
             </a:r>
             <a:endParaRPr lang="en-US" sz="1600" dirty="0"/>
           </a:p>
@@ -5922,9 +5922,9 @@
                 <a:solidFill>
                   <a:srgbClr val="151515"/>
                 </a:solidFill>
-                <a:latin typeface="Overpass SemiBold" pitchFamily="34" charset="0"/>
-                <a:ea typeface="Overpass SemiBold" pitchFamily="34" charset="-122"/>
-                <a:cs typeface="Overpass SemiBold" pitchFamily="34" charset="-120"/>
+                <a:latin typeface="Red Hat Display" pitchFamily="34" charset="0"/>
+                <a:ea typeface="Red Hat Display" pitchFamily="34" charset="-122"/>
+                <a:cs typeface="Red Hat Display" pitchFamily="34" charset="-120"/>
               </a:rPr>
               <a:t>The mesh changes the organizational shape</a:t>
             </a:r>
@@ -5947,7 +5947,7 @@
                 <a:ea typeface="Red Hat Text" pitchFamily="34" charset="-122"/>
                 <a:cs typeface="Red Hat Text" pitchFamily="34" charset="-120"/>
               </a:rPr>
-              <a:t>Instead of building a better center, decentralize ownership to the domain teams that produce the data. Each domain owns its data as a product — discoverable, addressable, trustworthy, self-describing.</a:t>
+              <a:t>Instead of building a better center, decentralize ownership to the domain teams that produce the data. Each domain owns its data as a product: discoverable, addressable, trustworthy, self-describing.</a:t>
             </a:r>
             <a:endParaRPr lang="en-US" sz="1600" dirty="0"/>
           </a:p>
@@ -5987,9 +5987,9 @@
                 <a:solidFill>
                   <a:srgbClr val="151515"/>
                 </a:solidFill>
-                <a:latin typeface="Overpass SemiBold" pitchFamily="34" charset="0"/>
-                <a:ea typeface="Overpass SemiBold" pitchFamily="34" charset="-122"/>
-                <a:cs typeface="Overpass SemiBold" pitchFamily="34" charset="-120"/>
+                <a:latin typeface="Red Hat Display" pitchFamily="34" charset="0"/>
+                <a:ea typeface="Red Hat Display" pitchFamily="34" charset="-122"/>
+                <a:cs typeface="Red Hat Display" pitchFamily="34" charset="-120"/>
               </a:rPr>
               <a:t>Not a replacement</a:t>
             </a:r>
@@ -6033,7 +6033,7 @@
                 <a:ea typeface="Red Hat Text" pitchFamily="34" charset="-122"/>
                 <a:cs typeface="Red Hat Text" pitchFamily="34" charset="-120"/>
               </a:rPr>
-              <a:t>The mesh earns its complexity in organizations with many domains, many consumers, and the maturity to operate federated ownership.</a:t>
+              <a:t>The mesh's added complexity pays off in organizations with many domains, many consumers, and the maturity to operate federated ownership.</a:t>
             </a:r>
             <a:endParaRPr lang="en-US" sz="1600" dirty="0"/>
           </a:p>

</xml_diff>